<commit_message>
fixed the bug with pressing F11 to set the application to fullscreen. when the rasbperry Pi is used on a display or a monitor
</commit_message>
<xml_diff>
--- a/slides/PreGame/Willkommen.pptx
+++ b/slides/PreGame/Willkommen.pptx
@@ -2,7 +2,7 @@
 <file path=ppt/presentation.xml><?xml version="1.0" encoding="utf-8"?>
 <p:presentation xmlns:a="http://schemas.openxmlformats.org/drawingml/2006/main" xmlns:r="http://schemas.openxmlformats.org/officeDocument/2006/relationships" xmlns:p="http://schemas.openxmlformats.org/presentationml/2006/main" saveSubsetFonts="1">
   <p:sldMasterIdLst>
-    <p:sldMasterId id="2147483648" r:id="rId1"/>
+    <p:sldMasterId id="2147483660" r:id="rId1"/>
   </p:sldMasterIdLst>
   <p:sldIdLst>
     <p:sldId id="256" r:id="rId2"/>
@@ -10,13 +10,13 @@
     <p:sldId id="258" r:id="rId4"/>
     <p:sldId id="259" r:id="rId5"/>
   </p:sldIdLst>
-  <p:sldSz cx="12192000" cy="6858000"/>
+  <p:sldSz cx="23039388" cy="11520488"/>
   <p:notesSz cx="6858000" cy="9144000"/>
   <p:defaultTextStyle>
     <a:defPPr>
-      <a:defRPr lang="de-DE"/>
+      <a:defRPr lang="en-US"/>
     </a:defPPr>
-    <a:lvl1pPr marL="0" algn="l" defTabSz="914400" rtl="0" eaLnBrk="1" latinLnBrk="0" hangingPunct="1">
+    <a:lvl1pPr marL="0" algn="l" defTabSz="457200" rtl="0" eaLnBrk="1" latinLnBrk="0" hangingPunct="1">
       <a:defRPr sz="1800" kern="1200">
         <a:solidFill>
           <a:schemeClr val="tx1"/>
@@ -26,7 +26,7 @@
         <a:cs typeface="+mn-cs"/>
       </a:defRPr>
     </a:lvl1pPr>
-    <a:lvl2pPr marL="457200" algn="l" defTabSz="914400" rtl="0" eaLnBrk="1" latinLnBrk="0" hangingPunct="1">
+    <a:lvl2pPr marL="457200" algn="l" defTabSz="457200" rtl="0" eaLnBrk="1" latinLnBrk="0" hangingPunct="1">
       <a:defRPr sz="1800" kern="1200">
         <a:solidFill>
           <a:schemeClr val="tx1"/>
@@ -36,7 +36,7 @@
         <a:cs typeface="+mn-cs"/>
       </a:defRPr>
     </a:lvl2pPr>
-    <a:lvl3pPr marL="914400" algn="l" defTabSz="914400" rtl="0" eaLnBrk="1" latinLnBrk="0" hangingPunct="1">
+    <a:lvl3pPr marL="914400" algn="l" defTabSz="457200" rtl="0" eaLnBrk="1" latinLnBrk="0" hangingPunct="1">
       <a:defRPr sz="1800" kern="1200">
         <a:solidFill>
           <a:schemeClr val="tx1"/>
@@ -46,7 +46,7 @@
         <a:cs typeface="+mn-cs"/>
       </a:defRPr>
     </a:lvl3pPr>
-    <a:lvl4pPr marL="1371600" algn="l" defTabSz="914400" rtl="0" eaLnBrk="1" latinLnBrk="0" hangingPunct="1">
+    <a:lvl4pPr marL="1371600" algn="l" defTabSz="457200" rtl="0" eaLnBrk="1" latinLnBrk="0" hangingPunct="1">
       <a:defRPr sz="1800" kern="1200">
         <a:solidFill>
           <a:schemeClr val="tx1"/>
@@ -56,7 +56,7 @@
         <a:cs typeface="+mn-cs"/>
       </a:defRPr>
     </a:lvl4pPr>
-    <a:lvl5pPr marL="1828800" algn="l" defTabSz="914400" rtl="0" eaLnBrk="1" latinLnBrk="0" hangingPunct="1">
+    <a:lvl5pPr marL="1828800" algn="l" defTabSz="457200" rtl="0" eaLnBrk="1" latinLnBrk="0" hangingPunct="1">
       <a:defRPr sz="1800" kern="1200">
         <a:solidFill>
           <a:schemeClr val="tx1"/>
@@ -66,7 +66,7 @@
         <a:cs typeface="+mn-cs"/>
       </a:defRPr>
     </a:lvl5pPr>
-    <a:lvl6pPr marL="2286000" algn="l" defTabSz="914400" rtl="0" eaLnBrk="1" latinLnBrk="0" hangingPunct="1">
+    <a:lvl6pPr marL="2286000" algn="l" defTabSz="457200" rtl="0" eaLnBrk="1" latinLnBrk="0" hangingPunct="1">
       <a:defRPr sz="1800" kern="1200">
         <a:solidFill>
           <a:schemeClr val="tx1"/>
@@ -76,7 +76,7 @@
         <a:cs typeface="+mn-cs"/>
       </a:defRPr>
     </a:lvl6pPr>
-    <a:lvl7pPr marL="2743200" algn="l" defTabSz="914400" rtl="0" eaLnBrk="1" latinLnBrk="0" hangingPunct="1">
+    <a:lvl7pPr marL="2743200" algn="l" defTabSz="457200" rtl="0" eaLnBrk="1" latinLnBrk="0" hangingPunct="1">
       <a:defRPr sz="1800" kern="1200">
         <a:solidFill>
           <a:schemeClr val="tx1"/>
@@ -86,7 +86,7 @@
         <a:cs typeface="+mn-cs"/>
       </a:defRPr>
     </a:lvl7pPr>
-    <a:lvl8pPr marL="3200400" algn="l" defTabSz="914400" rtl="0" eaLnBrk="1" latinLnBrk="0" hangingPunct="1">
+    <a:lvl8pPr marL="3200400" algn="l" defTabSz="457200" rtl="0" eaLnBrk="1" latinLnBrk="0" hangingPunct="1">
       <a:defRPr sz="1800" kern="1200">
         <a:solidFill>
           <a:schemeClr val="tx1"/>
@@ -96,7 +96,7 @@
         <a:cs typeface="+mn-cs"/>
       </a:defRPr>
     </a:lvl8pPr>
-    <a:lvl9pPr marL="3657600" algn="l" defTabSz="914400" rtl="0" eaLnBrk="1" latinLnBrk="0" hangingPunct="1">
+    <a:lvl9pPr marL="3657600" algn="l" defTabSz="457200" rtl="0" eaLnBrk="1" latinLnBrk="0" hangingPunct="1">
       <a:defRPr sz="1800" kern="1200">
         <a:solidFill>
           <a:schemeClr val="tx1"/>
@@ -134,13 +134,7 @@
       </p:grpSpPr>
       <p:sp>
         <p:nvSpPr>
-          <p:cNvPr id="2" name="Titel 1">
-            <a:extLst>
-              <a:ext uri="{FF2B5EF4-FFF2-40B4-BE49-F238E27FC236}">
-                <a16:creationId xmlns:a16="http://schemas.microsoft.com/office/drawing/2014/main" id="{603B3AEF-F178-9CC1-BA7F-566D96031F47}"/>
-              </a:ext>
-            </a:extLst>
-          </p:cNvPr>
+          <p:cNvPr id="2" name="Title 1"/>
           <p:cNvSpPr>
             <a:spLocks noGrp="1"/>
           </p:cNvSpPr>
@@ -150,15 +144,15 @@
         </p:nvSpPr>
         <p:spPr>
           <a:xfrm>
-            <a:off x="1524000" y="1122363"/>
-            <a:ext cx="9144000" cy="2387600"/>
+            <a:off x="2879924" y="1885414"/>
+            <a:ext cx="17279541" cy="4010837"/>
           </a:xfrm>
         </p:spPr>
         <p:txBody>
           <a:bodyPr anchor="b"/>
           <a:lstStyle>
             <a:lvl1pPr algn="ctr">
-              <a:defRPr sz="6000"/>
+              <a:defRPr sz="10079"/>
             </a:lvl1pPr>
           </a:lstStyle>
           <a:p>
@@ -166,19 +160,13 @@
               <a:rPr lang="de-DE"/>
               <a:t>Mastertitelformat bearbeiten</a:t>
             </a:r>
-            <a:endParaRPr lang="de-CH"/>
-          </a:p>
-        </p:txBody>
-      </p:sp>
-      <p:sp>
-        <p:nvSpPr>
-          <p:cNvPr id="3" name="Untertitel 2">
-            <a:extLst>
-              <a:ext uri="{FF2B5EF4-FFF2-40B4-BE49-F238E27FC236}">
-                <a16:creationId xmlns:a16="http://schemas.microsoft.com/office/drawing/2014/main" id="{5F571E89-07C7-6E6C-67B1-4C46D36E3FC0}"/>
-              </a:ext>
-            </a:extLst>
-          </p:cNvPr>
+            <a:endParaRPr lang="en-US" dirty="0"/>
+          </a:p>
+        </p:txBody>
+      </p:sp>
+      <p:sp>
+        <p:nvSpPr>
+          <p:cNvPr id="3" name="Subtitle 2"/>
           <p:cNvSpPr>
             <a:spLocks noGrp="1"/>
           </p:cNvSpPr>
@@ -188,8 +176,8 @@
         </p:nvSpPr>
         <p:spPr>
           <a:xfrm>
-            <a:off x="1524000" y="3602038"/>
-            <a:ext cx="9144000" cy="1655762"/>
+            <a:off x="2879924" y="6050924"/>
+            <a:ext cx="17279541" cy="2781450"/>
           </a:xfrm>
         </p:spPr>
         <p:txBody>
@@ -197,39 +185,39 @@
           <a:lstStyle>
             <a:lvl1pPr marL="0" indent="0" algn="ctr">
               <a:buNone/>
-              <a:defRPr sz="2400"/>
+              <a:defRPr sz="4032"/>
             </a:lvl1pPr>
-            <a:lvl2pPr marL="457200" indent="0" algn="ctr">
-              <a:buNone/>
-              <a:defRPr sz="2000"/>
+            <a:lvl2pPr marL="768050" indent="0" algn="ctr">
+              <a:buNone/>
+              <a:defRPr sz="3360"/>
             </a:lvl2pPr>
-            <a:lvl3pPr marL="914400" indent="0" algn="ctr">
-              <a:buNone/>
-              <a:defRPr sz="1800"/>
+            <a:lvl3pPr marL="1536101" indent="0" algn="ctr">
+              <a:buNone/>
+              <a:defRPr sz="3024"/>
             </a:lvl3pPr>
-            <a:lvl4pPr marL="1371600" indent="0" algn="ctr">
-              <a:buNone/>
-              <a:defRPr sz="1600"/>
+            <a:lvl4pPr marL="2304151" indent="0" algn="ctr">
+              <a:buNone/>
+              <a:defRPr sz="2688"/>
             </a:lvl4pPr>
-            <a:lvl5pPr marL="1828800" indent="0" algn="ctr">
-              <a:buNone/>
-              <a:defRPr sz="1600"/>
+            <a:lvl5pPr marL="3072201" indent="0" algn="ctr">
+              <a:buNone/>
+              <a:defRPr sz="2688"/>
             </a:lvl5pPr>
-            <a:lvl6pPr marL="2286000" indent="0" algn="ctr">
-              <a:buNone/>
-              <a:defRPr sz="1600"/>
+            <a:lvl6pPr marL="3840251" indent="0" algn="ctr">
+              <a:buNone/>
+              <a:defRPr sz="2688"/>
             </a:lvl6pPr>
-            <a:lvl7pPr marL="2743200" indent="0" algn="ctr">
-              <a:buNone/>
-              <a:defRPr sz="1600"/>
+            <a:lvl7pPr marL="4608302" indent="0" algn="ctr">
+              <a:buNone/>
+              <a:defRPr sz="2688"/>
             </a:lvl7pPr>
-            <a:lvl8pPr marL="3200400" indent="0" algn="ctr">
-              <a:buNone/>
-              <a:defRPr sz="1600"/>
+            <a:lvl8pPr marL="5376352" indent="0" algn="ctr">
+              <a:buNone/>
+              <a:defRPr sz="2688"/>
             </a:lvl8pPr>
-            <a:lvl9pPr marL="3657600" indent="0" algn="ctr">
-              <a:buNone/>
-              <a:defRPr sz="1600"/>
+            <a:lvl9pPr marL="6144402" indent="0" algn="ctr">
+              <a:buNone/>
+              <a:defRPr sz="2688"/>
             </a:lvl9pPr>
           </a:lstStyle>
           <a:p>
@@ -237,19 +225,13 @@
               <a:rPr lang="de-DE"/>
               <a:t>Master-Untertitelformat bearbeiten</a:t>
             </a:r>
-            <a:endParaRPr lang="de-CH"/>
-          </a:p>
-        </p:txBody>
-      </p:sp>
-      <p:sp>
-        <p:nvSpPr>
-          <p:cNvPr id="4" name="Datumsplatzhalter 3">
-            <a:extLst>
-              <a:ext uri="{FF2B5EF4-FFF2-40B4-BE49-F238E27FC236}">
-                <a16:creationId xmlns:a16="http://schemas.microsoft.com/office/drawing/2014/main" id="{02E16ECF-0F4E-1943-30AD-4448FE299FE9}"/>
-              </a:ext>
-            </a:extLst>
-          </p:cNvPr>
+            <a:endParaRPr lang="en-US" dirty="0"/>
+          </a:p>
+        </p:txBody>
+      </p:sp>
+      <p:sp>
+        <p:nvSpPr>
+          <p:cNvPr id="4" name="Date Placeholder 3"/>
           <p:cNvSpPr>
             <a:spLocks noGrp="1"/>
           </p:cNvSpPr>
@@ -264,7 +246,7 @@
           <a:p>
             <a:fld id="{18BF9560-8671-453D-AEEB-6496BE150E94}" type="datetimeFigureOut">
               <a:rPr lang="de-CH" smtClean="0"/>
-              <a:t>21.12.2025</a:t>
+              <a:t>02.06.2026</a:t>
             </a:fld>
             <a:endParaRPr lang="de-CH"/>
           </a:p>
@@ -272,13 +254,7 @@
       </p:sp>
       <p:sp>
         <p:nvSpPr>
-          <p:cNvPr id="5" name="Fußzeilenplatzhalter 4">
-            <a:extLst>
-              <a:ext uri="{FF2B5EF4-FFF2-40B4-BE49-F238E27FC236}">
-                <a16:creationId xmlns:a16="http://schemas.microsoft.com/office/drawing/2014/main" id="{30D15C0C-DEC3-7BB7-7BA4-A5631E0963F0}"/>
-              </a:ext>
-            </a:extLst>
-          </p:cNvPr>
+          <p:cNvPr id="5" name="Footer Placeholder 4"/>
           <p:cNvSpPr>
             <a:spLocks noGrp="1"/>
           </p:cNvSpPr>
@@ -297,13 +273,7 @@
       </p:sp>
       <p:sp>
         <p:nvSpPr>
-          <p:cNvPr id="6" name="Foliennummernplatzhalter 5">
-            <a:extLst>
-              <a:ext uri="{FF2B5EF4-FFF2-40B4-BE49-F238E27FC236}">
-                <a16:creationId xmlns:a16="http://schemas.microsoft.com/office/drawing/2014/main" id="{EECB3D05-3BE6-C041-1E77-B6DCE6072E1E}"/>
-              </a:ext>
-            </a:extLst>
-          </p:cNvPr>
+          <p:cNvPr id="6" name="Slide Number Placeholder 5"/>
           <p:cNvSpPr>
             <a:spLocks noGrp="1"/>
           </p:cNvSpPr>
@@ -327,7 +297,7 @@
     </p:spTree>
     <p:extLst>
       <p:ext uri="{BB962C8B-B14F-4D97-AF65-F5344CB8AC3E}">
-        <p14:creationId xmlns:p14="http://schemas.microsoft.com/office/powerpoint/2010/main" val="1723893625"/>
+        <p14:creationId xmlns:p14="http://schemas.microsoft.com/office/powerpoint/2010/main" val="2234681979"/>
       </p:ext>
     </p:extLst>
   </p:cSld>
@@ -356,13 +326,7 @@
       </p:grpSpPr>
       <p:sp>
         <p:nvSpPr>
-          <p:cNvPr id="2" name="Titel 1">
-            <a:extLst>
-              <a:ext uri="{FF2B5EF4-FFF2-40B4-BE49-F238E27FC236}">
-                <a16:creationId xmlns:a16="http://schemas.microsoft.com/office/drawing/2014/main" id="{84449E27-37B2-4228-3D72-21BE5147FCB1}"/>
-              </a:ext>
-            </a:extLst>
-          </p:cNvPr>
+          <p:cNvPr id="2" name="Title 1"/>
           <p:cNvSpPr>
             <a:spLocks noGrp="1"/>
           </p:cNvSpPr>
@@ -379,19 +343,13 @@
               <a:rPr lang="de-DE"/>
               <a:t>Mastertitelformat bearbeiten</a:t>
             </a:r>
-            <a:endParaRPr lang="de-CH"/>
-          </a:p>
-        </p:txBody>
-      </p:sp>
-      <p:sp>
-        <p:nvSpPr>
-          <p:cNvPr id="3" name="Vertikaler Textplatzhalter 2">
-            <a:extLst>
-              <a:ext uri="{FF2B5EF4-FFF2-40B4-BE49-F238E27FC236}">
-                <a16:creationId xmlns:a16="http://schemas.microsoft.com/office/drawing/2014/main" id="{E7649072-36DD-89B8-292F-4BFB413182D9}"/>
-              </a:ext>
-            </a:extLst>
-          </p:cNvPr>
+            <a:endParaRPr lang="en-US" dirty="0"/>
+          </a:p>
+        </p:txBody>
+      </p:sp>
+      <p:sp>
+        <p:nvSpPr>
+          <p:cNvPr id="3" name="Vertical Text Placeholder 2"/>
           <p:cNvSpPr>
             <a:spLocks noGrp="1"/>
           </p:cNvSpPr>
@@ -437,19 +395,13 @@
               <a:rPr lang="de-DE"/>
               <a:t>Fünfte Ebene</a:t>
             </a:r>
-            <a:endParaRPr lang="de-CH"/>
-          </a:p>
-        </p:txBody>
-      </p:sp>
-      <p:sp>
-        <p:nvSpPr>
-          <p:cNvPr id="4" name="Datumsplatzhalter 3">
-            <a:extLst>
-              <a:ext uri="{FF2B5EF4-FFF2-40B4-BE49-F238E27FC236}">
-                <a16:creationId xmlns:a16="http://schemas.microsoft.com/office/drawing/2014/main" id="{F6D5AFA1-64E1-8E13-0860-E145E48EC703}"/>
-              </a:ext>
-            </a:extLst>
-          </p:cNvPr>
+            <a:endParaRPr lang="en-US" dirty="0"/>
+          </a:p>
+        </p:txBody>
+      </p:sp>
+      <p:sp>
+        <p:nvSpPr>
+          <p:cNvPr id="4" name="Date Placeholder 3"/>
           <p:cNvSpPr>
             <a:spLocks noGrp="1"/>
           </p:cNvSpPr>
@@ -464,7 +416,7 @@
           <a:p>
             <a:fld id="{18BF9560-8671-453D-AEEB-6496BE150E94}" type="datetimeFigureOut">
               <a:rPr lang="de-CH" smtClean="0"/>
-              <a:t>21.12.2025</a:t>
+              <a:t>02.06.2026</a:t>
             </a:fld>
             <a:endParaRPr lang="de-CH"/>
           </a:p>
@@ -472,13 +424,7 @@
       </p:sp>
       <p:sp>
         <p:nvSpPr>
-          <p:cNvPr id="5" name="Fußzeilenplatzhalter 4">
-            <a:extLst>
-              <a:ext uri="{FF2B5EF4-FFF2-40B4-BE49-F238E27FC236}">
-                <a16:creationId xmlns:a16="http://schemas.microsoft.com/office/drawing/2014/main" id="{7B2C20EF-B58F-37EC-4AE3-13A2B863B3DD}"/>
-              </a:ext>
-            </a:extLst>
-          </p:cNvPr>
+          <p:cNvPr id="5" name="Footer Placeholder 4"/>
           <p:cNvSpPr>
             <a:spLocks noGrp="1"/>
           </p:cNvSpPr>
@@ -497,13 +443,7 @@
       </p:sp>
       <p:sp>
         <p:nvSpPr>
-          <p:cNvPr id="6" name="Foliennummernplatzhalter 5">
-            <a:extLst>
-              <a:ext uri="{FF2B5EF4-FFF2-40B4-BE49-F238E27FC236}">
-                <a16:creationId xmlns:a16="http://schemas.microsoft.com/office/drawing/2014/main" id="{D236DC00-1E29-8361-AA4E-5CADADFF39F1}"/>
-              </a:ext>
-            </a:extLst>
-          </p:cNvPr>
+          <p:cNvPr id="6" name="Slide Number Placeholder 5"/>
           <p:cNvSpPr>
             <a:spLocks noGrp="1"/>
           </p:cNvSpPr>
@@ -527,7 +467,7 @@
     </p:spTree>
     <p:extLst>
       <p:ext uri="{BB962C8B-B14F-4D97-AF65-F5344CB8AC3E}">
-        <p14:creationId xmlns:p14="http://schemas.microsoft.com/office/powerpoint/2010/main" val="2657433778"/>
+        <p14:creationId xmlns:p14="http://schemas.microsoft.com/office/powerpoint/2010/main" val="2213496784"/>
       </p:ext>
     </p:extLst>
   </p:cSld>
@@ -556,13 +496,7 @@
       </p:grpSpPr>
       <p:sp>
         <p:nvSpPr>
-          <p:cNvPr id="2" name="Vertikaler Titel 1">
-            <a:extLst>
-              <a:ext uri="{FF2B5EF4-FFF2-40B4-BE49-F238E27FC236}">
-                <a16:creationId xmlns:a16="http://schemas.microsoft.com/office/drawing/2014/main" id="{88C9E215-A6FB-6AC2-F15A-C4F8CFF3DC29}"/>
-              </a:ext>
-            </a:extLst>
-          </p:cNvPr>
+          <p:cNvPr id="2" name="Vertical Title 1"/>
           <p:cNvSpPr>
             <a:spLocks noGrp="1"/>
           </p:cNvSpPr>
@@ -572,8 +506,8 @@
         </p:nvSpPr>
         <p:spPr>
           <a:xfrm>
-            <a:off x="8724900" y="365125"/>
-            <a:ext cx="2628900" cy="5811838"/>
+            <a:off x="16487562" y="613359"/>
+            <a:ext cx="4967868" cy="9763081"/>
           </a:xfrm>
         </p:spPr>
         <p:txBody>
@@ -584,19 +518,13 @@
               <a:rPr lang="de-DE"/>
               <a:t>Mastertitelformat bearbeiten</a:t>
             </a:r>
-            <a:endParaRPr lang="de-CH"/>
-          </a:p>
-        </p:txBody>
-      </p:sp>
-      <p:sp>
-        <p:nvSpPr>
-          <p:cNvPr id="3" name="Vertikaler Textplatzhalter 2">
-            <a:extLst>
-              <a:ext uri="{FF2B5EF4-FFF2-40B4-BE49-F238E27FC236}">
-                <a16:creationId xmlns:a16="http://schemas.microsoft.com/office/drawing/2014/main" id="{F84F6B61-5C40-9D1B-E475-2B470AC81BA5}"/>
-              </a:ext>
-            </a:extLst>
-          </p:cNvPr>
+            <a:endParaRPr lang="en-US" dirty="0"/>
+          </a:p>
+        </p:txBody>
+      </p:sp>
+      <p:sp>
+        <p:nvSpPr>
+          <p:cNvPr id="3" name="Vertical Text Placeholder 2"/>
           <p:cNvSpPr>
             <a:spLocks noGrp="1"/>
           </p:cNvSpPr>
@@ -606,8 +534,8 @@
         </p:nvSpPr>
         <p:spPr>
           <a:xfrm>
-            <a:off x="838200" y="365125"/>
-            <a:ext cx="7734300" cy="5811838"/>
+            <a:off x="1583958" y="613359"/>
+            <a:ext cx="14615612" cy="9763081"/>
           </a:xfrm>
         </p:spPr>
         <p:txBody>
@@ -647,19 +575,13 @@
               <a:rPr lang="de-DE"/>
               <a:t>Fünfte Ebene</a:t>
             </a:r>
-            <a:endParaRPr lang="de-CH"/>
-          </a:p>
-        </p:txBody>
-      </p:sp>
-      <p:sp>
-        <p:nvSpPr>
-          <p:cNvPr id="4" name="Datumsplatzhalter 3">
-            <a:extLst>
-              <a:ext uri="{FF2B5EF4-FFF2-40B4-BE49-F238E27FC236}">
-                <a16:creationId xmlns:a16="http://schemas.microsoft.com/office/drawing/2014/main" id="{C4F2CA66-666B-F6F7-9F28-60183AE164B3}"/>
-              </a:ext>
-            </a:extLst>
-          </p:cNvPr>
+            <a:endParaRPr lang="en-US" dirty="0"/>
+          </a:p>
+        </p:txBody>
+      </p:sp>
+      <p:sp>
+        <p:nvSpPr>
+          <p:cNvPr id="4" name="Date Placeholder 3"/>
           <p:cNvSpPr>
             <a:spLocks noGrp="1"/>
           </p:cNvSpPr>
@@ -674,7 +596,7 @@
           <a:p>
             <a:fld id="{18BF9560-8671-453D-AEEB-6496BE150E94}" type="datetimeFigureOut">
               <a:rPr lang="de-CH" smtClean="0"/>
-              <a:t>21.12.2025</a:t>
+              <a:t>02.06.2026</a:t>
             </a:fld>
             <a:endParaRPr lang="de-CH"/>
           </a:p>
@@ -682,13 +604,7 @@
       </p:sp>
       <p:sp>
         <p:nvSpPr>
-          <p:cNvPr id="5" name="Fußzeilenplatzhalter 4">
-            <a:extLst>
-              <a:ext uri="{FF2B5EF4-FFF2-40B4-BE49-F238E27FC236}">
-                <a16:creationId xmlns:a16="http://schemas.microsoft.com/office/drawing/2014/main" id="{673ADD53-A5DB-17B8-1B5E-D01867193D22}"/>
-              </a:ext>
-            </a:extLst>
-          </p:cNvPr>
+          <p:cNvPr id="5" name="Footer Placeholder 4"/>
           <p:cNvSpPr>
             <a:spLocks noGrp="1"/>
           </p:cNvSpPr>
@@ -707,13 +623,7 @@
       </p:sp>
       <p:sp>
         <p:nvSpPr>
-          <p:cNvPr id="6" name="Foliennummernplatzhalter 5">
-            <a:extLst>
-              <a:ext uri="{FF2B5EF4-FFF2-40B4-BE49-F238E27FC236}">
-                <a16:creationId xmlns:a16="http://schemas.microsoft.com/office/drawing/2014/main" id="{9B404A45-EAD6-C713-2161-EEC0D6F837E6}"/>
-              </a:ext>
-            </a:extLst>
-          </p:cNvPr>
+          <p:cNvPr id="6" name="Slide Number Placeholder 5"/>
           <p:cNvSpPr>
             <a:spLocks noGrp="1"/>
           </p:cNvSpPr>
@@ -737,7 +647,7 @@
     </p:spTree>
     <p:extLst>
       <p:ext uri="{BB962C8B-B14F-4D97-AF65-F5344CB8AC3E}">
-        <p14:creationId xmlns:p14="http://schemas.microsoft.com/office/powerpoint/2010/main" val="4271222960"/>
+        <p14:creationId xmlns:p14="http://schemas.microsoft.com/office/powerpoint/2010/main" val="3716425024"/>
       </p:ext>
     </p:extLst>
   </p:cSld>
@@ -766,13 +676,7 @@
       </p:grpSpPr>
       <p:sp>
         <p:nvSpPr>
-          <p:cNvPr id="2" name="Titel 1">
-            <a:extLst>
-              <a:ext uri="{FF2B5EF4-FFF2-40B4-BE49-F238E27FC236}">
-                <a16:creationId xmlns:a16="http://schemas.microsoft.com/office/drawing/2014/main" id="{BFD6FDCB-1170-E842-4AD3-AC70BEB3B5ED}"/>
-              </a:ext>
-            </a:extLst>
-          </p:cNvPr>
+          <p:cNvPr id="2" name="Title 1"/>
           <p:cNvSpPr>
             <a:spLocks noGrp="1"/>
           </p:cNvSpPr>
@@ -789,19 +693,13 @@
               <a:rPr lang="de-DE"/>
               <a:t>Mastertitelformat bearbeiten</a:t>
             </a:r>
-            <a:endParaRPr lang="de-CH"/>
-          </a:p>
-        </p:txBody>
-      </p:sp>
-      <p:sp>
-        <p:nvSpPr>
-          <p:cNvPr id="3" name="Inhaltsplatzhalter 2">
-            <a:extLst>
-              <a:ext uri="{FF2B5EF4-FFF2-40B4-BE49-F238E27FC236}">
-                <a16:creationId xmlns:a16="http://schemas.microsoft.com/office/drawing/2014/main" id="{90042FDD-2611-DBA2-B5E2-7AE601EE55F5}"/>
-              </a:ext>
-            </a:extLst>
-          </p:cNvPr>
+            <a:endParaRPr lang="en-US" dirty="0"/>
+          </a:p>
+        </p:txBody>
+      </p:sp>
+      <p:sp>
+        <p:nvSpPr>
+          <p:cNvPr id="3" name="Content Placeholder 2"/>
           <p:cNvSpPr>
             <a:spLocks noGrp="1"/>
           </p:cNvSpPr>
@@ -847,19 +745,13 @@
               <a:rPr lang="de-DE"/>
               <a:t>Fünfte Ebene</a:t>
             </a:r>
-            <a:endParaRPr lang="de-CH"/>
-          </a:p>
-        </p:txBody>
-      </p:sp>
-      <p:sp>
-        <p:nvSpPr>
-          <p:cNvPr id="4" name="Datumsplatzhalter 3">
-            <a:extLst>
-              <a:ext uri="{FF2B5EF4-FFF2-40B4-BE49-F238E27FC236}">
-                <a16:creationId xmlns:a16="http://schemas.microsoft.com/office/drawing/2014/main" id="{1D6FED39-79B4-149E-A093-4B7D3E43C175}"/>
-              </a:ext>
-            </a:extLst>
-          </p:cNvPr>
+            <a:endParaRPr lang="en-US" dirty="0"/>
+          </a:p>
+        </p:txBody>
+      </p:sp>
+      <p:sp>
+        <p:nvSpPr>
+          <p:cNvPr id="4" name="Date Placeholder 3"/>
           <p:cNvSpPr>
             <a:spLocks noGrp="1"/>
           </p:cNvSpPr>
@@ -874,7 +766,7 @@
           <a:p>
             <a:fld id="{18BF9560-8671-453D-AEEB-6496BE150E94}" type="datetimeFigureOut">
               <a:rPr lang="de-CH" smtClean="0"/>
-              <a:t>21.12.2025</a:t>
+              <a:t>02.06.2026</a:t>
             </a:fld>
             <a:endParaRPr lang="de-CH"/>
           </a:p>
@@ -882,13 +774,7 @@
       </p:sp>
       <p:sp>
         <p:nvSpPr>
-          <p:cNvPr id="5" name="Fußzeilenplatzhalter 4">
-            <a:extLst>
-              <a:ext uri="{FF2B5EF4-FFF2-40B4-BE49-F238E27FC236}">
-                <a16:creationId xmlns:a16="http://schemas.microsoft.com/office/drawing/2014/main" id="{83BEBE02-48C0-3C24-64D9-2779F6D7D11D}"/>
-              </a:ext>
-            </a:extLst>
-          </p:cNvPr>
+          <p:cNvPr id="5" name="Footer Placeholder 4"/>
           <p:cNvSpPr>
             <a:spLocks noGrp="1"/>
           </p:cNvSpPr>
@@ -907,13 +793,7 @@
       </p:sp>
       <p:sp>
         <p:nvSpPr>
-          <p:cNvPr id="6" name="Foliennummernplatzhalter 5">
-            <a:extLst>
-              <a:ext uri="{FF2B5EF4-FFF2-40B4-BE49-F238E27FC236}">
-                <a16:creationId xmlns:a16="http://schemas.microsoft.com/office/drawing/2014/main" id="{13AD5226-6DD4-90F9-8CFA-9E8F850864F2}"/>
-              </a:ext>
-            </a:extLst>
-          </p:cNvPr>
+          <p:cNvPr id="6" name="Slide Number Placeholder 5"/>
           <p:cNvSpPr>
             <a:spLocks noGrp="1"/>
           </p:cNvSpPr>
@@ -937,7 +817,7 @@
     </p:spTree>
     <p:extLst>
       <p:ext uri="{BB962C8B-B14F-4D97-AF65-F5344CB8AC3E}">
-        <p14:creationId xmlns:p14="http://schemas.microsoft.com/office/powerpoint/2010/main" val="830487331"/>
+        <p14:creationId xmlns:p14="http://schemas.microsoft.com/office/powerpoint/2010/main" val="533935532"/>
       </p:ext>
     </p:extLst>
   </p:cSld>
@@ -966,13 +846,7 @@
       </p:grpSpPr>
       <p:sp>
         <p:nvSpPr>
-          <p:cNvPr id="2" name="Titel 1">
-            <a:extLst>
-              <a:ext uri="{FF2B5EF4-FFF2-40B4-BE49-F238E27FC236}">
-                <a16:creationId xmlns:a16="http://schemas.microsoft.com/office/drawing/2014/main" id="{F59B140A-4644-B841-C5B5-2A7EB81244C5}"/>
-              </a:ext>
-            </a:extLst>
-          </p:cNvPr>
+          <p:cNvPr id="2" name="Title 1"/>
           <p:cNvSpPr>
             <a:spLocks noGrp="1"/>
           </p:cNvSpPr>
@@ -982,15 +856,15 @@
         </p:nvSpPr>
         <p:spPr>
           <a:xfrm>
-            <a:off x="831850" y="1709738"/>
-            <a:ext cx="10515600" cy="2852737"/>
+            <a:off x="1571958" y="2872123"/>
+            <a:ext cx="19871472" cy="4792202"/>
           </a:xfrm>
         </p:spPr>
         <p:txBody>
           <a:bodyPr anchor="b"/>
           <a:lstStyle>
             <a:lvl1pPr>
-              <a:defRPr sz="6000"/>
+              <a:defRPr sz="10079"/>
             </a:lvl1pPr>
           </a:lstStyle>
           <a:p>
@@ -998,19 +872,13 @@
               <a:rPr lang="de-DE"/>
               <a:t>Mastertitelformat bearbeiten</a:t>
             </a:r>
-            <a:endParaRPr lang="de-CH"/>
-          </a:p>
-        </p:txBody>
-      </p:sp>
-      <p:sp>
-        <p:nvSpPr>
-          <p:cNvPr id="3" name="Textplatzhalter 2">
-            <a:extLst>
-              <a:ext uri="{FF2B5EF4-FFF2-40B4-BE49-F238E27FC236}">
-                <a16:creationId xmlns:a16="http://schemas.microsoft.com/office/drawing/2014/main" id="{CDAAF782-7F45-6B25-99D8-5F2E88B0378F}"/>
-              </a:ext>
-            </a:extLst>
-          </p:cNvPr>
+            <a:endParaRPr lang="en-US" dirty="0"/>
+          </a:p>
+        </p:txBody>
+      </p:sp>
+      <p:sp>
+        <p:nvSpPr>
+          <p:cNvPr id="3" name="Text Placeholder 2"/>
           <p:cNvSpPr>
             <a:spLocks noGrp="1"/>
           </p:cNvSpPr>
@@ -1020,8 +888,8 @@
         </p:nvSpPr>
         <p:spPr>
           <a:xfrm>
-            <a:off x="831850" y="4589463"/>
-            <a:ext cx="10515600" cy="1500187"/>
+            <a:off x="1571958" y="7709662"/>
+            <a:ext cx="19871472" cy="2520106"/>
           </a:xfrm>
         </p:spPr>
         <p:txBody>
@@ -1029,7 +897,7 @@
           <a:lstStyle>
             <a:lvl1pPr marL="0" indent="0">
               <a:buNone/>
-              <a:defRPr sz="2400">
+              <a:defRPr sz="4032">
                 <a:solidFill>
                   <a:schemeClr val="tx1">
                     <a:tint val="82000"/>
@@ -1037,9 +905,9 @@
                 </a:solidFill>
               </a:defRPr>
             </a:lvl1pPr>
-            <a:lvl2pPr marL="457200" indent="0">
-              <a:buNone/>
-              <a:defRPr sz="2000">
+            <a:lvl2pPr marL="768050" indent="0">
+              <a:buNone/>
+              <a:defRPr sz="3360">
                 <a:solidFill>
                   <a:schemeClr val="tx1">
                     <a:tint val="82000"/>
@@ -1047,9 +915,9 @@
                 </a:solidFill>
               </a:defRPr>
             </a:lvl2pPr>
-            <a:lvl3pPr marL="914400" indent="0">
-              <a:buNone/>
-              <a:defRPr sz="1800">
+            <a:lvl3pPr marL="1536101" indent="0">
+              <a:buNone/>
+              <a:defRPr sz="3024">
                 <a:solidFill>
                   <a:schemeClr val="tx1">
                     <a:tint val="82000"/>
@@ -1057,9 +925,9 @@
                 </a:solidFill>
               </a:defRPr>
             </a:lvl3pPr>
-            <a:lvl4pPr marL="1371600" indent="0">
-              <a:buNone/>
-              <a:defRPr sz="1600">
+            <a:lvl4pPr marL="2304151" indent="0">
+              <a:buNone/>
+              <a:defRPr sz="2688">
                 <a:solidFill>
                   <a:schemeClr val="tx1">
                     <a:tint val="82000"/>
@@ -1067,9 +935,9 @@
                 </a:solidFill>
               </a:defRPr>
             </a:lvl4pPr>
-            <a:lvl5pPr marL="1828800" indent="0">
-              <a:buNone/>
-              <a:defRPr sz="1600">
+            <a:lvl5pPr marL="3072201" indent="0">
+              <a:buNone/>
+              <a:defRPr sz="2688">
                 <a:solidFill>
                   <a:schemeClr val="tx1">
                     <a:tint val="82000"/>
@@ -1077,9 +945,9 @@
                 </a:solidFill>
               </a:defRPr>
             </a:lvl5pPr>
-            <a:lvl6pPr marL="2286000" indent="0">
-              <a:buNone/>
-              <a:defRPr sz="1600">
+            <a:lvl6pPr marL="3840251" indent="0">
+              <a:buNone/>
+              <a:defRPr sz="2688">
                 <a:solidFill>
                   <a:schemeClr val="tx1">
                     <a:tint val="82000"/>
@@ -1087,9 +955,9 @@
                 </a:solidFill>
               </a:defRPr>
             </a:lvl6pPr>
-            <a:lvl7pPr marL="2743200" indent="0">
-              <a:buNone/>
-              <a:defRPr sz="1600">
+            <a:lvl7pPr marL="4608302" indent="0">
+              <a:buNone/>
+              <a:defRPr sz="2688">
                 <a:solidFill>
                   <a:schemeClr val="tx1">
                     <a:tint val="82000"/>
@@ -1097,9 +965,9 @@
                 </a:solidFill>
               </a:defRPr>
             </a:lvl7pPr>
-            <a:lvl8pPr marL="3200400" indent="0">
-              <a:buNone/>
-              <a:defRPr sz="1600">
+            <a:lvl8pPr marL="5376352" indent="0">
+              <a:buNone/>
+              <a:defRPr sz="2688">
                 <a:solidFill>
                   <a:schemeClr val="tx1">
                     <a:tint val="82000"/>
@@ -1107,9 +975,9 @@
                 </a:solidFill>
               </a:defRPr>
             </a:lvl8pPr>
-            <a:lvl9pPr marL="3657600" indent="0">
-              <a:buNone/>
-              <a:defRPr sz="1600">
+            <a:lvl9pPr marL="6144402" indent="0">
+              <a:buNone/>
+              <a:defRPr sz="2688">
                 <a:solidFill>
                   <a:schemeClr val="tx1">
                     <a:tint val="82000"/>
@@ -1129,13 +997,7 @@
       </p:sp>
       <p:sp>
         <p:nvSpPr>
-          <p:cNvPr id="4" name="Datumsplatzhalter 3">
-            <a:extLst>
-              <a:ext uri="{FF2B5EF4-FFF2-40B4-BE49-F238E27FC236}">
-                <a16:creationId xmlns:a16="http://schemas.microsoft.com/office/drawing/2014/main" id="{EA57A514-10F4-E893-152B-CE1F62B94B1E}"/>
-              </a:ext>
-            </a:extLst>
-          </p:cNvPr>
+          <p:cNvPr id="4" name="Date Placeholder 3"/>
           <p:cNvSpPr>
             <a:spLocks noGrp="1"/>
           </p:cNvSpPr>
@@ -1150,7 +1012,7 @@
           <a:p>
             <a:fld id="{18BF9560-8671-453D-AEEB-6496BE150E94}" type="datetimeFigureOut">
               <a:rPr lang="de-CH" smtClean="0"/>
-              <a:t>21.12.2025</a:t>
+              <a:t>02.06.2026</a:t>
             </a:fld>
             <a:endParaRPr lang="de-CH"/>
           </a:p>
@@ -1158,13 +1020,7 @@
       </p:sp>
       <p:sp>
         <p:nvSpPr>
-          <p:cNvPr id="5" name="Fußzeilenplatzhalter 4">
-            <a:extLst>
-              <a:ext uri="{FF2B5EF4-FFF2-40B4-BE49-F238E27FC236}">
-                <a16:creationId xmlns:a16="http://schemas.microsoft.com/office/drawing/2014/main" id="{D2DF0C1A-3B69-E32C-B887-687B6B95EF7C}"/>
-              </a:ext>
-            </a:extLst>
-          </p:cNvPr>
+          <p:cNvPr id="5" name="Footer Placeholder 4"/>
           <p:cNvSpPr>
             <a:spLocks noGrp="1"/>
           </p:cNvSpPr>
@@ -1183,13 +1039,7 @@
       </p:sp>
       <p:sp>
         <p:nvSpPr>
-          <p:cNvPr id="6" name="Foliennummernplatzhalter 5">
-            <a:extLst>
-              <a:ext uri="{FF2B5EF4-FFF2-40B4-BE49-F238E27FC236}">
-                <a16:creationId xmlns:a16="http://schemas.microsoft.com/office/drawing/2014/main" id="{18FB72F3-CBF4-7569-683E-FD6A7B00EDF4}"/>
-              </a:ext>
-            </a:extLst>
-          </p:cNvPr>
+          <p:cNvPr id="6" name="Slide Number Placeholder 5"/>
           <p:cNvSpPr>
             <a:spLocks noGrp="1"/>
           </p:cNvSpPr>
@@ -1213,7 +1063,7 @@
     </p:spTree>
     <p:extLst>
       <p:ext uri="{BB962C8B-B14F-4D97-AF65-F5344CB8AC3E}">
-        <p14:creationId xmlns:p14="http://schemas.microsoft.com/office/powerpoint/2010/main" val="1456374967"/>
+        <p14:creationId xmlns:p14="http://schemas.microsoft.com/office/powerpoint/2010/main" val="2257984234"/>
       </p:ext>
     </p:extLst>
   </p:cSld>
@@ -1242,13 +1092,7 @@
       </p:grpSpPr>
       <p:sp>
         <p:nvSpPr>
-          <p:cNvPr id="2" name="Titel 1">
-            <a:extLst>
-              <a:ext uri="{FF2B5EF4-FFF2-40B4-BE49-F238E27FC236}">
-                <a16:creationId xmlns:a16="http://schemas.microsoft.com/office/drawing/2014/main" id="{BEBF59EF-5C3F-3FE3-4A73-1D4C1C698BAC}"/>
-              </a:ext>
-            </a:extLst>
-          </p:cNvPr>
+          <p:cNvPr id="2" name="Title 1"/>
           <p:cNvSpPr>
             <a:spLocks noGrp="1"/>
           </p:cNvSpPr>
@@ -1265,19 +1109,13 @@
               <a:rPr lang="de-DE"/>
               <a:t>Mastertitelformat bearbeiten</a:t>
             </a:r>
-            <a:endParaRPr lang="de-CH"/>
-          </a:p>
-        </p:txBody>
-      </p:sp>
-      <p:sp>
-        <p:nvSpPr>
-          <p:cNvPr id="3" name="Inhaltsplatzhalter 2">
-            <a:extLst>
-              <a:ext uri="{FF2B5EF4-FFF2-40B4-BE49-F238E27FC236}">
-                <a16:creationId xmlns:a16="http://schemas.microsoft.com/office/drawing/2014/main" id="{A7641055-D1AD-8A68-0811-410A78550693}"/>
-              </a:ext>
-            </a:extLst>
-          </p:cNvPr>
+            <a:endParaRPr lang="en-US" dirty="0"/>
+          </a:p>
+        </p:txBody>
+      </p:sp>
+      <p:sp>
+        <p:nvSpPr>
+          <p:cNvPr id="3" name="Content Placeholder 2"/>
           <p:cNvSpPr>
             <a:spLocks noGrp="1"/>
           </p:cNvSpPr>
@@ -1287,8 +1125,8 @@
         </p:nvSpPr>
         <p:spPr>
           <a:xfrm>
-            <a:off x="838200" y="1825625"/>
-            <a:ext cx="5181600" cy="4351338"/>
+            <a:off x="1583958" y="3066796"/>
+            <a:ext cx="9791740" cy="7309644"/>
           </a:xfrm>
         </p:spPr>
         <p:txBody>
@@ -1328,19 +1166,13 @@
               <a:rPr lang="de-DE"/>
               <a:t>Fünfte Ebene</a:t>
             </a:r>
-            <a:endParaRPr lang="de-CH"/>
-          </a:p>
-        </p:txBody>
-      </p:sp>
-      <p:sp>
-        <p:nvSpPr>
-          <p:cNvPr id="4" name="Inhaltsplatzhalter 3">
-            <a:extLst>
-              <a:ext uri="{FF2B5EF4-FFF2-40B4-BE49-F238E27FC236}">
-                <a16:creationId xmlns:a16="http://schemas.microsoft.com/office/drawing/2014/main" id="{98CC7511-0787-1D05-47FD-4F201D5974DB}"/>
-              </a:ext>
-            </a:extLst>
-          </p:cNvPr>
+            <a:endParaRPr lang="en-US" dirty="0"/>
+          </a:p>
+        </p:txBody>
+      </p:sp>
+      <p:sp>
+        <p:nvSpPr>
+          <p:cNvPr id="4" name="Content Placeholder 3"/>
           <p:cNvSpPr>
             <a:spLocks noGrp="1"/>
           </p:cNvSpPr>
@@ -1350,8 +1182,8 @@
         </p:nvSpPr>
         <p:spPr>
           <a:xfrm>
-            <a:off x="6172200" y="1825625"/>
-            <a:ext cx="5181600" cy="4351338"/>
+            <a:off x="11663690" y="3066796"/>
+            <a:ext cx="9791740" cy="7309644"/>
           </a:xfrm>
         </p:spPr>
         <p:txBody>
@@ -1391,19 +1223,13 @@
               <a:rPr lang="de-DE"/>
               <a:t>Fünfte Ebene</a:t>
             </a:r>
-            <a:endParaRPr lang="de-CH"/>
-          </a:p>
-        </p:txBody>
-      </p:sp>
-      <p:sp>
-        <p:nvSpPr>
-          <p:cNvPr id="5" name="Datumsplatzhalter 4">
-            <a:extLst>
-              <a:ext uri="{FF2B5EF4-FFF2-40B4-BE49-F238E27FC236}">
-                <a16:creationId xmlns:a16="http://schemas.microsoft.com/office/drawing/2014/main" id="{62E6C3FE-E5D5-9582-04C8-269AE205E31F}"/>
-              </a:ext>
-            </a:extLst>
-          </p:cNvPr>
+            <a:endParaRPr lang="en-US" dirty="0"/>
+          </a:p>
+        </p:txBody>
+      </p:sp>
+      <p:sp>
+        <p:nvSpPr>
+          <p:cNvPr id="5" name="Date Placeholder 4"/>
           <p:cNvSpPr>
             <a:spLocks noGrp="1"/>
           </p:cNvSpPr>
@@ -1418,7 +1244,7 @@
           <a:p>
             <a:fld id="{18BF9560-8671-453D-AEEB-6496BE150E94}" type="datetimeFigureOut">
               <a:rPr lang="de-CH" smtClean="0"/>
-              <a:t>21.12.2025</a:t>
+              <a:t>02.06.2026</a:t>
             </a:fld>
             <a:endParaRPr lang="de-CH"/>
           </a:p>
@@ -1426,13 +1252,7 @@
       </p:sp>
       <p:sp>
         <p:nvSpPr>
-          <p:cNvPr id="6" name="Fußzeilenplatzhalter 5">
-            <a:extLst>
-              <a:ext uri="{FF2B5EF4-FFF2-40B4-BE49-F238E27FC236}">
-                <a16:creationId xmlns:a16="http://schemas.microsoft.com/office/drawing/2014/main" id="{D19E6605-C23E-7930-48CA-3402F6FFA314}"/>
-              </a:ext>
-            </a:extLst>
-          </p:cNvPr>
+          <p:cNvPr id="6" name="Footer Placeholder 5"/>
           <p:cNvSpPr>
             <a:spLocks noGrp="1"/>
           </p:cNvSpPr>
@@ -1451,13 +1271,7 @@
       </p:sp>
       <p:sp>
         <p:nvSpPr>
-          <p:cNvPr id="7" name="Foliennummernplatzhalter 6">
-            <a:extLst>
-              <a:ext uri="{FF2B5EF4-FFF2-40B4-BE49-F238E27FC236}">
-                <a16:creationId xmlns:a16="http://schemas.microsoft.com/office/drawing/2014/main" id="{6B2BAF1F-B0C7-3955-48CC-EA1F38C09E97}"/>
-              </a:ext>
-            </a:extLst>
-          </p:cNvPr>
+          <p:cNvPr id="7" name="Slide Number Placeholder 6"/>
           <p:cNvSpPr>
             <a:spLocks noGrp="1"/>
           </p:cNvSpPr>
@@ -1481,7 +1295,7 @@
     </p:spTree>
     <p:extLst>
       <p:ext uri="{BB962C8B-B14F-4D97-AF65-F5344CB8AC3E}">
-        <p14:creationId xmlns:p14="http://schemas.microsoft.com/office/powerpoint/2010/main" val="2449639549"/>
+        <p14:creationId xmlns:p14="http://schemas.microsoft.com/office/powerpoint/2010/main" val="2236259089"/>
       </p:ext>
     </p:extLst>
   </p:cSld>
@@ -1510,13 +1324,7 @@
       </p:grpSpPr>
       <p:sp>
         <p:nvSpPr>
-          <p:cNvPr id="2" name="Titel 1">
-            <a:extLst>
-              <a:ext uri="{FF2B5EF4-FFF2-40B4-BE49-F238E27FC236}">
-                <a16:creationId xmlns:a16="http://schemas.microsoft.com/office/drawing/2014/main" id="{7C32E2A7-4258-C9D1-290B-1D5E261F3B7C}"/>
-              </a:ext>
-            </a:extLst>
-          </p:cNvPr>
+          <p:cNvPr id="2" name="Title 1"/>
           <p:cNvSpPr>
             <a:spLocks noGrp="1"/>
           </p:cNvSpPr>
@@ -1526,8 +1334,8 @@
         </p:nvSpPr>
         <p:spPr>
           <a:xfrm>
-            <a:off x="839788" y="365125"/>
-            <a:ext cx="10515600" cy="1325563"/>
+            <a:off x="1586959" y="613360"/>
+            <a:ext cx="19871472" cy="2226762"/>
           </a:xfrm>
         </p:spPr>
         <p:txBody>
@@ -1538,19 +1346,13 @@
               <a:rPr lang="de-DE"/>
               <a:t>Mastertitelformat bearbeiten</a:t>
             </a:r>
-            <a:endParaRPr lang="de-CH"/>
-          </a:p>
-        </p:txBody>
-      </p:sp>
-      <p:sp>
-        <p:nvSpPr>
-          <p:cNvPr id="3" name="Textplatzhalter 2">
-            <a:extLst>
-              <a:ext uri="{FF2B5EF4-FFF2-40B4-BE49-F238E27FC236}">
-                <a16:creationId xmlns:a16="http://schemas.microsoft.com/office/drawing/2014/main" id="{0E1708BA-CA44-DA74-C653-A30026834044}"/>
-              </a:ext>
-            </a:extLst>
-          </p:cNvPr>
+            <a:endParaRPr lang="en-US" dirty="0"/>
+          </a:p>
+        </p:txBody>
+      </p:sp>
+      <p:sp>
+        <p:nvSpPr>
+          <p:cNvPr id="3" name="Text Placeholder 2"/>
           <p:cNvSpPr>
             <a:spLocks noGrp="1"/>
           </p:cNvSpPr>
@@ -1560,8 +1362,8 @@
         </p:nvSpPr>
         <p:spPr>
           <a:xfrm>
-            <a:off x="839788" y="1681163"/>
-            <a:ext cx="5157787" cy="823912"/>
+            <a:off x="1586960" y="2824120"/>
+            <a:ext cx="9746740" cy="1384058"/>
           </a:xfrm>
         </p:spPr>
         <p:txBody>
@@ -1569,39 +1371,39 @@
           <a:lstStyle>
             <a:lvl1pPr marL="0" indent="0">
               <a:buNone/>
-              <a:defRPr sz="2400" b="1"/>
+              <a:defRPr sz="4032" b="1"/>
             </a:lvl1pPr>
-            <a:lvl2pPr marL="457200" indent="0">
-              <a:buNone/>
-              <a:defRPr sz="2000" b="1"/>
+            <a:lvl2pPr marL="768050" indent="0">
+              <a:buNone/>
+              <a:defRPr sz="3360" b="1"/>
             </a:lvl2pPr>
-            <a:lvl3pPr marL="914400" indent="0">
-              <a:buNone/>
-              <a:defRPr sz="1800" b="1"/>
+            <a:lvl3pPr marL="1536101" indent="0">
+              <a:buNone/>
+              <a:defRPr sz="3024" b="1"/>
             </a:lvl3pPr>
-            <a:lvl4pPr marL="1371600" indent="0">
-              <a:buNone/>
-              <a:defRPr sz="1600" b="1"/>
+            <a:lvl4pPr marL="2304151" indent="0">
+              <a:buNone/>
+              <a:defRPr sz="2688" b="1"/>
             </a:lvl4pPr>
-            <a:lvl5pPr marL="1828800" indent="0">
-              <a:buNone/>
-              <a:defRPr sz="1600" b="1"/>
+            <a:lvl5pPr marL="3072201" indent="0">
+              <a:buNone/>
+              <a:defRPr sz="2688" b="1"/>
             </a:lvl5pPr>
-            <a:lvl6pPr marL="2286000" indent="0">
-              <a:buNone/>
-              <a:defRPr sz="1600" b="1"/>
+            <a:lvl6pPr marL="3840251" indent="0">
+              <a:buNone/>
+              <a:defRPr sz="2688" b="1"/>
             </a:lvl6pPr>
-            <a:lvl7pPr marL="2743200" indent="0">
-              <a:buNone/>
-              <a:defRPr sz="1600" b="1"/>
+            <a:lvl7pPr marL="4608302" indent="0">
+              <a:buNone/>
+              <a:defRPr sz="2688" b="1"/>
             </a:lvl7pPr>
-            <a:lvl8pPr marL="3200400" indent="0">
-              <a:buNone/>
-              <a:defRPr sz="1600" b="1"/>
+            <a:lvl8pPr marL="5376352" indent="0">
+              <a:buNone/>
+              <a:defRPr sz="2688" b="1"/>
             </a:lvl8pPr>
-            <a:lvl9pPr marL="3657600" indent="0">
-              <a:buNone/>
-              <a:defRPr sz="1600" b="1"/>
+            <a:lvl9pPr marL="6144402" indent="0">
+              <a:buNone/>
+              <a:defRPr sz="2688" b="1"/>
             </a:lvl9pPr>
           </a:lstStyle>
           <a:p>
@@ -1615,13 +1417,7 @@
       </p:sp>
       <p:sp>
         <p:nvSpPr>
-          <p:cNvPr id="4" name="Inhaltsplatzhalter 3">
-            <a:extLst>
-              <a:ext uri="{FF2B5EF4-FFF2-40B4-BE49-F238E27FC236}">
-                <a16:creationId xmlns:a16="http://schemas.microsoft.com/office/drawing/2014/main" id="{9AFFC61E-D86D-F04B-6FFE-B0FF526E1550}"/>
-              </a:ext>
-            </a:extLst>
-          </p:cNvPr>
+          <p:cNvPr id="4" name="Content Placeholder 3"/>
           <p:cNvSpPr>
             <a:spLocks noGrp="1"/>
           </p:cNvSpPr>
@@ -1631,8 +1427,8 @@
         </p:nvSpPr>
         <p:spPr>
           <a:xfrm>
-            <a:off x="839788" y="2505075"/>
-            <a:ext cx="5157787" cy="3684588"/>
+            <a:off x="1586960" y="4208178"/>
+            <a:ext cx="9746740" cy="6189596"/>
           </a:xfrm>
         </p:spPr>
         <p:txBody>
@@ -1672,19 +1468,13 @@
               <a:rPr lang="de-DE"/>
               <a:t>Fünfte Ebene</a:t>
             </a:r>
-            <a:endParaRPr lang="de-CH"/>
-          </a:p>
-        </p:txBody>
-      </p:sp>
-      <p:sp>
-        <p:nvSpPr>
-          <p:cNvPr id="5" name="Textplatzhalter 4">
-            <a:extLst>
-              <a:ext uri="{FF2B5EF4-FFF2-40B4-BE49-F238E27FC236}">
-                <a16:creationId xmlns:a16="http://schemas.microsoft.com/office/drawing/2014/main" id="{29437996-138D-77AC-F86A-D938A26A459C}"/>
-              </a:ext>
-            </a:extLst>
-          </p:cNvPr>
+            <a:endParaRPr lang="en-US" dirty="0"/>
+          </a:p>
+        </p:txBody>
+      </p:sp>
+      <p:sp>
+        <p:nvSpPr>
+          <p:cNvPr id="5" name="Text Placeholder 4"/>
           <p:cNvSpPr>
             <a:spLocks noGrp="1"/>
           </p:cNvSpPr>
@@ -1694,8 +1484,8 @@
         </p:nvSpPr>
         <p:spPr>
           <a:xfrm>
-            <a:off x="6172200" y="1681163"/>
-            <a:ext cx="5183188" cy="823912"/>
+            <a:off x="11663690" y="2824120"/>
+            <a:ext cx="9794741" cy="1384058"/>
           </a:xfrm>
         </p:spPr>
         <p:txBody>
@@ -1703,39 +1493,39 @@
           <a:lstStyle>
             <a:lvl1pPr marL="0" indent="0">
               <a:buNone/>
-              <a:defRPr sz="2400" b="1"/>
+              <a:defRPr sz="4032" b="1"/>
             </a:lvl1pPr>
-            <a:lvl2pPr marL="457200" indent="0">
-              <a:buNone/>
-              <a:defRPr sz="2000" b="1"/>
+            <a:lvl2pPr marL="768050" indent="0">
+              <a:buNone/>
+              <a:defRPr sz="3360" b="1"/>
             </a:lvl2pPr>
-            <a:lvl3pPr marL="914400" indent="0">
-              <a:buNone/>
-              <a:defRPr sz="1800" b="1"/>
+            <a:lvl3pPr marL="1536101" indent="0">
+              <a:buNone/>
+              <a:defRPr sz="3024" b="1"/>
             </a:lvl3pPr>
-            <a:lvl4pPr marL="1371600" indent="0">
-              <a:buNone/>
-              <a:defRPr sz="1600" b="1"/>
+            <a:lvl4pPr marL="2304151" indent="0">
+              <a:buNone/>
+              <a:defRPr sz="2688" b="1"/>
             </a:lvl4pPr>
-            <a:lvl5pPr marL="1828800" indent="0">
-              <a:buNone/>
-              <a:defRPr sz="1600" b="1"/>
+            <a:lvl5pPr marL="3072201" indent="0">
+              <a:buNone/>
+              <a:defRPr sz="2688" b="1"/>
             </a:lvl5pPr>
-            <a:lvl6pPr marL="2286000" indent="0">
-              <a:buNone/>
-              <a:defRPr sz="1600" b="1"/>
+            <a:lvl6pPr marL="3840251" indent="0">
+              <a:buNone/>
+              <a:defRPr sz="2688" b="1"/>
             </a:lvl6pPr>
-            <a:lvl7pPr marL="2743200" indent="0">
-              <a:buNone/>
-              <a:defRPr sz="1600" b="1"/>
+            <a:lvl7pPr marL="4608302" indent="0">
+              <a:buNone/>
+              <a:defRPr sz="2688" b="1"/>
             </a:lvl7pPr>
-            <a:lvl8pPr marL="3200400" indent="0">
-              <a:buNone/>
-              <a:defRPr sz="1600" b="1"/>
+            <a:lvl8pPr marL="5376352" indent="0">
+              <a:buNone/>
+              <a:defRPr sz="2688" b="1"/>
             </a:lvl8pPr>
-            <a:lvl9pPr marL="3657600" indent="0">
-              <a:buNone/>
-              <a:defRPr sz="1600" b="1"/>
+            <a:lvl9pPr marL="6144402" indent="0">
+              <a:buNone/>
+              <a:defRPr sz="2688" b="1"/>
             </a:lvl9pPr>
           </a:lstStyle>
           <a:p>
@@ -1749,13 +1539,7 @@
       </p:sp>
       <p:sp>
         <p:nvSpPr>
-          <p:cNvPr id="6" name="Inhaltsplatzhalter 5">
-            <a:extLst>
-              <a:ext uri="{FF2B5EF4-FFF2-40B4-BE49-F238E27FC236}">
-                <a16:creationId xmlns:a16="http://schemas.microsoft.com/office/drawing/2014/main" id="{100FE1B8-52CB-9D2B-A9A2-49520724278D}"/>
-              </a:ext>
-            </a:extLst>
-          </p:cNvPr>
+          <p:cNvPr id="6" name="Content Placeholder 5"/>
           <p:cNvSpPr>
             <a:spLocks noGrp="1"/>
           </p:cNvSpPr>
@@ -1765,8 +1549,8 @@
         </p:nvSpPr>
         <p:spPr>
           <a:xfrm>
-            <a:off x="6172200" y="2505075"/>
-            <a:ext cx="5183188" cy="3684588"/>
+            <a:off x="11663690" y="4208178"/>
+            <a:ext cx="9794741" cy="6189596"/>
           </a:xfrm>
         </p:spPr>
         <p:txBody>
@@ -1806,19 +1590,13 @@
               <a:rPr lang="de-DE"/>
               <a:t>Fünfte Ebene</a:t>
             </a:r>
-            <a:endParaRPr lang="de-CH"/>
-          </a:p>
-        </p:txBody>
-      </p:sp>
-      <p:sp>
-        <p:nvSpPr>
-          <p:cNvPr id="7" name="Datumsplatzhalter 6">
-            <a:extLst>
-              <a:ext uri="{FF2B5EF4-FFF2-40B4-BE49-F238E27FC236}">
-                <a16:creationId xmlns:a16="http://schemas.microsoft.com/office/drawing/2014/main" id="{1BB4DBB8-C30B-36AA-CD4C-F9E66A88255C}"/>
-              </a:ext>
-            </a:extLst>
-          </p:cNvPr>
+            <a:endParaRPr lang="en-US" dirty="0"/>
+          </a:p>
+        </p:txBody>
+      </p:sp>
+      <p:sp>
+        <p:nvSpPr>
+          <p:cNvPr id="7" name="Date Placeholder 6"/>
           <p:cNvSpPr>
             <a:spLocks noGrp="1"/>
           </p:cNvSpPr>
@@ -1833,7 +1611,7 @@
           <a:p>
             <a:fld id="{18BF9560-8671-453D-AEEB-6496BE150E94}" type="datetimeFigureOut">
               <a:rPr lang="de-CH" smtClean="0"/>
-              <a:t>21.12.2025</a:t>
+              <a:t>02.06.2026</a:t>
             </a:fld>
             <a:endParaRPr lang="de-CH"/>
           </a:p>
@@ -1841,13 +1619,7 @@
       </p:sp>
       <p:sp>
         <p:nvSpPr>
-          <p:cNvPr id="8" name="Fußzeilenplatzhalter 7">
-            <a:extLst>
-              <a:ext uri="{FF2B5EF4-FFF2-40B4-BE49-F238E27FC236}">
-                <a16:creationId xmlns:a16="http://schemas.microsoft.com/office/drawing/2014/main" id="{4C0788A6-FC49-0F4F-146D-36CE092E747C}"/>
-              </a:ext>
-            </a:extLst>
-          </p:cNvPr>
+          <p:cNvPr id="8" name="Footer Placeholder 7"/>
           <p:cNvSpPr>
             <a:spLocks noGrp="1"/>
           </p:cNvSpPr>
@@ -1866,13 +1638,7 @@
       </p:sp>
       <p:sp>
         <p:nvSpPr>
-          <p:cNvPr id="9" name="Foliennummernplatzhalter 8">
-            <a:extLst>
-              <a:ext uri="{FF2B5EF4-FFF2-40B4-BE49-F238E27FC236}">
-                <a16:creationId xmlns:a16="http://schemas.microsoft.com/office/drawing/2014/main" id="{43CD2F6B-AE76-AC0D-8D0D-ACDC65249D55}"/>
-              </a:ext>
-            </a:extLst>
-          </p:cNvPr>
+          <p:cNvPr id="9" name="Slide Number Placeholder 8"/>
           <p:cNvSpPr>
             <a:spLocks noGrp="1"/>
           </p:cNvSpPr>
@@ -1896,7 +1662,7 @@
     </p:spTree>
     <p:extLst>
       <p:ext uri="{BB962C8B-B14F-4D97-AF65-F5344CB8AC3E}">
-        <p14:creationId xmlns:p14="http://schemas.microsoft.com/office/powerpoint/2010/main" val="3046182718"/>
+        <p14:creationId xmlns:p14="http://schemas.microsoft.com/office/powerpoint/2010/main" val="1679161170"/>
       </p:ext>
     </p:extLst>
   </p:cSld>
@@ -1925,13 +1691,7 @@
       </p:grpSpPr>
       <p:sp>
         <p:nvSpPr>
-          <p:cNvPr id="2" name="Titel 1">
-            <a:extLst>
-              <a:ext uri="{FF2B5EF4-FFF2-40B4-BE49-F238E27FC236}">
-                <a16:creationId xmlns:a16="http://schemas.microsoft.com/office/drawing/2014/main" id="{D7DF3B2D-8862-958A-8F4F-2BD5B4AA64A5}"/>
-              </a:ext>
-            </a:extLst>
-          </p:cNvPr>
+          <p:cNvPr id="2" name="Title 1"/>
           <p:cNvSpPr>
             <a:spLocks noGrp="1"/>
           </p:cNvSpPr>
@@ -1948,19 +1708,13 @@
               <a:rPr lang="de-DE"/>
               <a:t>Mastertitelformat bearbeiten</a:t>
             </a:r>
-            <a:endParaRPr lang="de-CH"/>
-          </a:p>
-        </p:txBody>
-      </p:sp>
-      <p:sp>
-        <p:nvSpPr>
-          <p:cNvPr id="3" name="Datumsplatzhalter 2">
-            <a:extLst>
-              <a:ext uri="{FF2B5EF4-FFF2-40B4-BE49-F238E27FC236}">
-                <a16:creationId xmlns:a16="http://schemas.microsoft.com/office/drawing/2014/main" id="{07DB315E-6E4B-AC5B-EF21-F89EBA29F10A}"/>
-              </a:ext>
-            </a:extLst>
-          </p:cNvPr>
+            <a:endParaRPr lang="en-US" dirty="0"/>
+          </a:p>
+        </p:txBody>
+      </p:sp>
+      <p:sp>
+        <p:nvSpPr>
+          <p:cNvPr id="3" name="Date Placeholder 2"/>
           <p:cNvSpPr>
             <a:spLocks noGrp="1"/>
           </p:cNvSpPr>
@@ -1975,7 +1729,7 @@
           <a:p>
             <a:fld id="{18BF9560-8671-453D-AEEB-6496BE150E94}" type="datetimeFigureOut">
               <a:rPr lang="de-CH" smtClean="0"/>
-              <a:t>21.12.2025</a:t>
+              <a:t>02.06.2026</a:t>
             </a:fld>
             <a:endParaRPr lang="de-CH"/>
           </a:p>
@@ -1983,13 +1737,7 @@
       </p:sp>
       <p:sp>
         <p:nvSpPr>
-          <p:cNvPr id="4" name="Fußzeilenplatzhalter 3">
-            <a:extLst>
-              <a:ext uri="{FF2B5EF4-FFF2-40B4-BE49-F238E27FC236}">
-                <a16:creationId xmlns:a16="http://schemas.microsoft.com/office/drawing/2014/main" id="{BBD75FAB-53AE-BFF9-15B3-8E92F64B0737}"/>
-              </a:ext>
-            </a:extLst>
-          </p:cNvPr>
+          <p:cNvPr id="4" name="Footer Placeholder 3"/>
           <p:cNvSpPr>
             <a:spLocks noGrp="1"/>
           </p:cNvSpPr>
@@ -2008,13 +1756,7 @@
       </p:sp>
       <p:sp>
         <p:nvSpPr>
-          <p:cNvPr id="5" name="Foliennummernplatzhalter 4">
-            <a:extLst>
-              <a:ext uri="{FF2B5EF4-FFF2-40B4-BE49-F238E27FC236}">
-                <a16:creationId xmlns:a16="http://schemas.microsoft.com/office/drawing/2014/main" id="{E9ABD53F-F514-1391-203D-80714B556107}"/>
-              </a:ext>
-            </a:extLst>
-          </p:cNvPr>
+          <p:cNvPr id="5" name="Slide Number Placeholder 4"/>
           <p:cNvSpPr>
             <a:spLocks noGrp="1"/>
           </p:cNvSpPr>
@@ -2038,7 +1780,7 @@
     </p:spTree>
     <p:extLst>
       <p:ext uri="{BB962C8B-B14F-4D97-AF65-F5344CB8AC3E}">
-        <p14:creationId xmlns:p14="http://schemas.microsoft.com/office/powerpoint/2010/main" val="64191187"/>
+        <p14:creationId xmlns:p14="http://schemas.microsoft.com/office/powerpoint/2010/main" val="2514555851"/>
       </p:ext>
     </p:extLst>
   </p:cSld>
@@ -2067,13 +1809,7 @@
       </p:grpSpPr>
       <p:sp>
         <p:nvSpPr>
-          <p:cNvPr id="2" name="Datumsplatzhalter 1">
-            <a:extLst>
-              <a:ext uri="{FF2B5EF4-FFF2-40B4-BE49-F238E27FC236}">
-                <a16:creationId xmlns:a16="http://schemas.microsoft.com/office/drawing/2014/main" id="{6113D021-014E-7250-E32D-F11BD19AA3AE}"/>
-              </a:ext>
-            </a:extLst>
-          </p:cNvPr>
+          <p:cNvPr id="2" name="Date Placeholder 1"/>
           <p:cNvSpPr>
             <a:spLocks noGrp="1"/>
           </p:cNvSpPr>
@@ -2088,7 +1824,7 @@
           <a:p>
             <a:fld id="{18BF9560-8671-453D-AEEB-6496BE150E94}" type="datetimeFigureOut">
               <a:rPr lang="de-CH" smtClean="0"/>
-              <a:t>21.12.2025</a:t>
+              <a:t>02.06.2026</a:t>
             </a:fld>
             <a:endParaRPr lang="de-CH"/>
           </a:p>
@@ -2096,13 +1832,7 @@
       </p:sp>
       <p:sp>
         <p:nvSpPr>
-          <p:cNvPr id="3" name="Fußzeilenplatzhalter 2">
-            <a:extLst>
-              <a:ext uri="{FF2B5EF4-FFF2-40B4-BE49-F238E27FC236}">
-                <a16:creationId xmlns:a16="http://schemas.microsoft.com/office/drawing/2014/main" id="{A25487D7-F6A5-940F-5FE5-7509FF3482A6}"/>
-              </a:ext>
-            </a:extLst>
-          </p:cNvPr>
+          <p:cNvPr id="3" name="Footer Placeholder 2"/>
           <p:cNvSpPr>
             <a:spLocks noGrp="1"/>
           </p:cNvSpPr>
@@ -2121,13 +1851,7 @@
       </p:sp>
       <p:sp>
         <p:nvSpPr>
-          <p:cNvPr id="4" name="Foliennummernplatzhalter 3">
-            <a:extLst>
-              <a:ext uri="{FF2B5EF4-FFF2-40B4-BE49-F238E27FC236}">
-                <a16:creationId xmlns:a16="http://schemas.microsoft.com/office/drawing/2014/main" id="{CBBCEF05-B651-623B-D3A6-B4CB2136F964}"/>
-              </a:ext>
-            </a:extLst>
-          </p:cNvPr>
+          <p:cNvPr id="4" name="Slide Number Placeholder 3"/>
           <p:cNvSpPr>
             <a:spLocks noGrp="1"/>
           </p:cNvSpPr>
@@ -2151,7 +1875,7 @@
     </p:spTree>
     <p:extLst>
       <p:ext uri="{BB962C8B-B14F-4D97-AF65-F5344CB8AC3E}">
-        <p14:creationId xmlns:p14="http://schemas.microsoft.com/office/powerpoint/2010/main" val="1257711104"/>
+        <p14:creationId xmlns:p14="http://schemas.microsoft.com/office/powerpoint/2010/main" val="838700877"/>
       </p:ext>
     </p:extLst>
   </p:cSld>
@@ -2180,13 +1904,7 @@
       </p:grpSpPr>
       <p:sp>
         <p:nvSpPr>
-          <p:cNvPr id="2" name="Titel 1">
-            <a:extLst>
-              <a:ext uri="{FF2B5EF4-FFF2-40B4-BE49-F238E27FC236}">
-                <a16:creationId xmlns:a16="http://schemas.microsoft.com/office/drawing/2014/main" id="{7B6AF00C-CB4B-0FC1-AA7A-6FBFA33A5679}"/>
-              </a:ext>
-            </a:extLst>
-          </p:cNvPr>
+          <p:cNvPr id="2" name="Title 1"/>
           <p:cNvSpPr>
             <a:spLocks noGrp="1"/>
           </p:cNvSpPr>
@@ -2196,15 +1914,15 @@
         </p:nvSpPr>
         <p:spPr>
           <a:xfrm>
-            <a:off x="839788" y="457200"/>
-            <a:ext cx="3932237" cy="1600200"/>
+            <a:off x="1586960" y="768032"/>
+            <a:ext cx="7430802" cy="2688114"/>
           </a:xfrm>
         </p:spPr>
         <p:txBody>
           <a:bodyPr anchor="b"/>
           <a:lstStyle>
             <a:lvl1pPr>
-              <a:defRPr sz="3200"/>
+              <a:defRPr sz="5376"/>
             </a:lvl1pPr>
           </a:lstStyle>
           <a:p>
@@ -2212,19 +1930,13 @@
               <a:rPr lang="de-DE"/>
               <a:t>Mastertitelformat bearbeiten</a:t>
             </a:r>
-            <a:endParaRPr lang="de-CH"/>
-          </a:p>
-        </p:txBody>
-      </p:sp>
-      <p:sp>
-        <p:nvSpPr>
-          <p:cNvPr id="3" name="Inhaltsplatzhalter 2">
-            <a:extLst>
-              <a:ext uri="{FF2B5EF4-FFF2-40B4-BE49-F238E27FC236}">
-                <a16:creationId xmlns:a16="http://schemas.microsoft.com/office/drawing/2014/main" id="{11B62902-BF00-2ED2-AFE3-C7274E6408FA}"/>
-              </a:ext>
-            </a:extLst>
-          </p:cNvPr>
+            <a:endParaRPr lang="en-US" dirty="0"/>
+          </a:p>
+        </p:txBody>
+      </p:sp>
+      <p:sp>
+        <p:nvSpPr>
+          <p:cNvPr id="3" name="Content Placeholder 2"/>
           <p:cNvSpPr>
             <a:spLocks noGrp="1"/>
           </p:cNvSpPr>
@@ -2234,39 +1946,39 @@
         </p:nvSpPr>
         <p:spPr>
           <a:xfrm>
-            <a:off x="5183188" y="987425"/>
-            <a:ext cx="6172200" cy="4873625"/>
+            <a:off x="9794741" y="1658738"/>
+            <a:ext cx="11663690" cy="8187013"/>
           </a:xfrm>
         </p:spPr>
         <p:txBody>
           <a:bodyPr/>
           <a:lstStyle>
             <a:lvl1pPr>
-              <a:defRPr sz="3200"/>
+              <a:defRPr sz="5376"/>
             </a:lvl1pPr>
             <a:lvl2pPr>
-              <a:defRPr sz="2800"/>
+              <a:defRPr sz="4704"/>
             </a:lvl2pPr>
             <a:lvl3pPr>
-              <a:defRPr sz="2400"/>
+              <a:defRPr sz="4032"/>
             </a:lvl3pPr>
             <a:lvl4pPr>
-              <a:defRPr sz="2000"/>
+              <a:defRPr sz="3360"/>
             </a:lvl4pPr>
             <a:lvl5pPr>
-              <a:defRPr sz="2000"/>
+              <a:defRPr sz="3360"/>
             </a:lvl5pPr>
             <a:lvl6pPr>
-              <a:defRPr sz="2000"/>
+              <a:defRPr sz="3360"/>
             </a:lvl6pPr>
             <a:lvl7pPr>
-              <a:defRPr sz="2000"/>
+              <a:defRPr sz="3360"/>
             </a:lvl7pPr>
             <a:lvl8pPr>
-              <a:defRPr sz="2000"/>
+              <a:defRPr sz="3360"/>
             </a:lvl8pPr>
             <a:lvl9pPr>
-              <a:defRPr sz="2000"/>
+              <a:defRPr sz="3360"/>
             </a:lvl9pPr>
           </a:lstStyle>
           <a:p>
@@ -2303,19 +2015,13 @@
               <a:rPr lang="de-DE"/>
               <a:t>Fünfte Ebene</a:t>
             </a:r>
-            <a:endParaRPr lang="de-CH"/>
-          </a:p>
-        </p:txBody>
-      </p:sp>
-      <p:sp>
-        <p:nvSpPr>
-          <p:cNvPr id="4" name="Textplatzhalter 3">
-            <a:extLst>
-              <a:ext uri="{FF2B5EF4-FFF2-40B4-BE49-F238E27FC236}">
-                <a16:creationId xmlns:a16="http://schemas.microsoft.com/office/drawing/2014/main" id="{27083751-15C9-8092-94A4-3FA7277D5BB2}"/>
-              </a:ext>
-            </a:extLst>
-          </p:cNvPr>
+            <a:endParaRPr lang="en-US" dirty="0"/>
+          </a:p>
+        </p:txBody>
+      </p:sp>
+      <p:sp>
+        <p:nvSpPr>
+          <p:cNvPr id="4" name="Text Placeholder 3"/>
           <p:cNvSpPr>
             <a:spLocks noGrp="1"/>
           </p:cNvSpPr>
@@ -2325,8 +2031,8 @@
         </p:nvSpPr>
         <p:spPr>
           <a:xfrm>
-            <a:off x="839788" y="2057400"/>
-            <a:ext cx="3932237" cy="3811588"/>
+            <a:off x="1586960" y="3456146"/>
+            <a:ext cx="7430802" cy="6402939"/>
           </a:xfrm>
         </p:spPr>
         <p:txBody>
@@ -2334,39 +2040,39 @@
           <a:lstStyle>
             <a:lvl1pPr marL="0" indent="0">
               <a:buNone/>
-              <a:defRPr sz="1600"/>
+              <a:defRPr sz="2688"/>
             </a:lvl1pPr>
-            <a:lvl2pPr marL="457200" indent="0">
-              <a:buNone/>
-              <a:defRPr sz="1400"/>
+            <a:lvl2pPr marL="768050" indent="0">
+              <a:buNone/>
+              <a:defRPr sz="2352"/>
             </a:lvl2pPr>
-            <a:lvl3pPr marL="914400" indent="0">
-              <a:buNone/>
-              <a:defRPr sz="1200"/>
+            <a:lvl3pPr marL="1536101" indent="0">
+              <a:buNone/>
+              <a:defRPr sz="2016"/>
             </a:lvl3pPr>
-            <a:lvl4pPr marL="1371600" indent="0">
-              <a:buNone/>
-              <a:defRPr sz="1000"/>
+            <a:lvl4pPr marL="2304151" indent="0">
+              <a:buNone/>
+              <a:defRPr sz="1680"/>
             </a:lvl4pPr>
-            <a:lvl5pPr marL="1828800" indent="0">
-              <a:buNone/>
-              <a:defRPr sz="1000"/>
+            <a:lvl5pPr marL="3072201" indent="0">
+              <a:buNone/>
+              <a:defRPr sz="1680"/>
             </a:lvl5pPr>
-            <a:lvl6pPr marL="2286000" indent="0">
-              <a:buNone/>
-              <a:defRPr sz="1000"/>
+            <a:lvl6pPr marL="3840251" indent="0">
+              <a:buNone/>
+              <a:defRPr sz="1680"/>
             </a:lvl6pPr>
-            <a:lvl7pPr marL="2743200" indent="0">
-              <a:buNone/>
-              <a:defRPr sz="1000"/>
+            <a:lvl7pPr marL="4608302" indent="0">
+              <a:buNone/>
+              <a:defRPr sz="1680"/>
             </a:lvl7pPr>
-            <a:lvl8pPr marL="3200400" indent="0">
-              <a:buNone/>
-              <a:defRPr sz="1000"/>
+            <a:lvl8pPr marL="5376352" indent="0">
+              <a:buNone/>
+              <a:defRPr sz="1680"/>
             </a:lvl8pPr>
-            <a:lvl9pPr marL="3657600" indent="0">
-              <a:buNone/>
-              <a:defRPr sz="1000"/>
+            <a:lvl9pPr marL="6144402" indent="0">
+              <a:buNone/>
+              <a:defRPr sz="1680"/>
             </a:lvl9pPr>
           </a:lstStyle>
           <a:p>
@@ -2380,13 +2086,7 @@
       </p:sp>
       <p:sp>
         <p:nvSpPr>
-          <p:cNvPr id="5" name="Datumsplatzhalter 4">
-            <a:extLst>
-              <a:ext uri="{FF2B5EF4-FFF2-40B4-BE49-F238E27FC236}">
-                <a16:creationId xmlns:a16="http://schemas.microsoft.com/office/drawing/2014/main" id="{4516660C-3C89-527F-A5D1-E4678BC959C8}"/>
-              </a:ext>
-            </a:extLst>
-          </p:cNvPr>
+          <p:cNvPr id="5" name="Date Placeholder 4"/>
           <p:cNvSpPr>
             <a:spLocks noGrp="1"/>
           </p:cNvSpPr>
@@ -2401,7 +2101,7 @@
           <a:p>
             <a:fld id="{18BF9560-8671-453D-AEEB-6496BE150E94}" type="datetimeFigureOut">
               <a:rPr lang="de-CH" smtClean="0"/>
-              <a:t>21.12.2025</a:t>
+              <a:t>02.06.2026</a:t>
             </a:fld>
             <a:endParaRPr lang="de-CH"/>
           </a:p>
@@ -2409,13 +2109,7 @@
       </p:sp>
       <p:sp>
         <p:nvSpPr>
-          <p:cNvPr id="6" name="Fußzeilenplatzhalter 5">
-            <a:extLst>
-              <a:ext uri="{FF2B5EF4-FFF2-40B4-BE49-F238E27FC236}">
-                <a16:creationId xmlns:a16="http://schemas.microsoft.com/office/drawing/2014/main" id="{5CC83901-7A21-F356-0ACE-F63CB4A18528}"/>
-              </a:ext>
-            </a:extLst>
-          </p:cNvPr>
+          <p:cNvPr id="6" name="Footer Placeholder 5"/>
           <p:cNvSpPr>
             <a:spLocks noGrp="1"/>
           </p:cNvSpPr>
@@ -2434,13 +2128,7 @@
       </p:sp>
       <p:sp>
         <p:nvSpPr>
-          <p:cNvPr id="7" name="Foliennummernplatzhalter 6">
-            <a:extLst>
-              <a:ext uri="{FF2B5EF4-FFF2-40B4-BE49-F238E27FC236}">
-                <a16:creationId xmlns:a16="http://schemas.microsoft.com/office/drawing/2014/main" id="{C72601AB-92D9-61F1-626F-71BBD2C4A876}"/>
-              </a:ext>
-            </a:extLst>
-          </p:cNvPr>
+          <p:cNvPr id="7" name="Slide Number Placeholder 6"/>
           <p:cNvSpPr>
             <a:spLocks noGrp="1"/>
           </p:cNvSpPr>
@@ -2464,7 +2152,7 @@
     </p:spTree>
     <p:extLst>
       <p:ext uri="{BB962C8B-B14F-4D97-AF65-F5344CB8AC3E}">
-        <p14:creationId xmlns:p14="http://schemas.microsoft.com/office/powerpoint/2010/main" val="1488419447"/>
+        <p14:creationId xmlns:p14="http://schemas.microsoft.com/office/powerpoint/2010/main" val="3552821892"/>
       </p:ext>
     </p:extLst>
   </p:cSld>
@@ -2493,13 +2181,7 @@
       </p:grpSpPr>
       <p:sp>
         <p:nvSpPr>
-          <p:cNvPr id="2" name="Titel 1">
-            <a:extLst>
-              <a:ext uri="{FF2B5EF4-FFF2-40B4-BE49-F238E27FC236}">
-                <a16:creationId xmlns:a16="http://schemas.microsoft.com/office/drawing/2014/main" id="{E9EDA440-A2A0-3933-1EC6-1071ADB68ECE}"/>
-              </a:ext>
-            </a:extLst>
-          </p:cNvPr>
+          <p:cNvPr id="2" name="Title 1"/>
           <p:cNvSpPr>
             <a:spLocks noGrp="1"/>
           </p:cNvSpPr>
@@ -2509,15 +2191,15 @@
         </p:nvSpPr>
         <p:spPr>
           <a:xfrm>
-            <a:off x="839788" y="457200"/>
-            <a:ext cx="3932237" cy="1600200"/>
+            <a:off x="1586960" y="768032"/>
+            <a:ext cx="7430802" cy="2688114"/>
           </a:xfrm>
         </p:spPr>
         <p:txBody>
           <a:bodyPr anchor="b"/>
           <a:lstStyle>
             <a:lvl1pPr>
-              <a:defRPr sz="3200"/>
+              <a:defRPr sz="5376"/>
             </a:lvl1pPr>
           </a:lstStyle>
           <a:p>
@@ -2525,21 +2207,15 @@
               <a:rPr lang="de-DE"/>
               <a:t>Mastertitelformat bearbeiten</a:t>
             </a:r>
-            <a:endParaRPr lang="de-CH"/>
-          </a:p>
-        </p:txBody>
-      </p:sp>
-      <p:sp>
-        <p:nvSpPr>
-          <p:cNvPr id="3" name="Bildplatzhalter 2">
-            <a:extLst>
-              <a:ext uri="{FF2B5EF4-FFF2-40B4-BE49-F238E27FC236}">
-                <a16:creationId xmlns:a16="http://schemas.microsoft.com/office/drawing/2014/main" id="{42C8A479-5CED-B706-953B-1FCBF47D98CD}"/>
-              </a:ext>
-            </a:extLst>
-          </p:cNvPr>
-          <p:cNvSpPr>
-            <a:spLocks noGrp="1"/>
+            <a:endParaRPr lang="en-US" dirty="0"/>
+          </a:p>
+        </p:txBody>
+      </p:sp>
+      <p:sp>
+        <p:nvSpPr>
+          <p:cNvPr id="3" name="Picture Placeholder 2"/>
+          <p:cNvSpPr>
+            <a:spLocks noGrp="1" noChangeAspect="1"/>
           </p:cNvSpPr>
           <p:nvPr>
             <p:ph type="pic" idx="1"/>
@@ -2547,64 +2223,62 @@
         </p:nvSpPr>
         <p:spPr>
           <a:xfrm>
-            <a:off x="5183188" y="987425"/>
-            <a:ext cx="6172200" cy="4873625"/>
+            <a:off x="9794741" y="1658738"/>
+            <a:ext cx="11663690" cy="8187013"/>
           </a:xfrm>
         </p:spPr>
         <p:txBody>
-          <a:bodyPr/>
+          <a:bodyPr anchor="t"/>
           <a:lstStyle>
             <a:lvl1pPr marL="0" indent="0">
               <a:buNone/>
-              <a:defRPr sz="3200"/>
+              <a:defRPr sz="5376"/>
             </a:lvl1pPr>
-            <a:lvl2pPr marL="457200" indent="0">
-              <a:buNone/>
-              <a:defRPr sz="2800"/>
+            <a:lvl2pPr marL="768050" indent="0">
+              <a:buNone/>
+              <a:defRPr sz="4704"/>
             </a:lvl2pPr>
-            <a:lvl3pPr marL="914400" indent="0">
-              <a:buNone/>
-              <a:defRPr sz="2400"/>
+            <a:lvl3pPr marL="1536101" indent="0">
+              <a:buNone/>
+              <a:defRPr sz="4032"/>
             </a:lvl3pPr>
-            <a:lvl4pPr marL="1371600" indent="0">
-              <a:buNone/>
-              <a:defRPr sz="2000"/>
+            <a:lvl4pPr marL="2304151" indent="0">
+              <a:buNone/>
+              <a:defRPr sz="3360"/>
             </a:lvl4pPr>
-            <a:lvl5pPr marL="1828800" indent="0">
-              <a:buNone/>
-              <a:defRPr sz="2000"/>
+            <a:lvl5pPr marL="3072201" indent="0">
+              <a:buNone/>
+              <a:defRPr sz="3360"/>
             </a:lvl5pPr>
-            <a:lvl6pPr marL="2286000" indent="0">
-              <a:buNone/>
-              <a:defRPr sz="2000"/>
+            <a:lvl6pPr marL="3840251" indent="0">
+              <a:buNone/>
+              <a:defRPr sz="3360"/>
             </a:lvl6pPr>
-            <a:lvl7pPr marL="2743200" indent="0">
-              <a:buNone/>
-              <a:defRPr sz="2000"/>
+            <a:lvl7pPr marL="4608302" indent="0">
+              <a:buNone/>
+              <a:defRPr sz="3360"/>
             </a:lvl7pPr>
-            <a:lvl8pPr marL="3200400" indent="0">
-              <a:buNone/>
-              <a:defRPr sz="2000"/>
+            <a:lvl8pPr marL="5376352" indent="0">
+              <a:buNone/>
+              <a:defRPr sz="3360"/>
             </a:lvl8pPr>
-            <a:lvl9pPr marL="3657600" indent="0">
-              <a:buNone/>
-              <a:defRPr sz="2000"/>
+            <a:lvl9pPr marL="6144402" indent="0">
+              <a:buNone/>
+              <a:defRPr sz="3360"/>
             </a:lvl9pPr>
           </a:lstStyle>
           <a:p>
-            <a:endParaRPr lang="de-CH"/>
-          </a:p>
-        </p:txBody>
-      </p:sp>
-      <p:sp>
-        <p:nvSpPr>
-          <p:cNvPr id="4" name="Textplatzhalter 3">
-            <a:extLst>
-              <a:ext uri="{FF2B5EF4-FFF2-40B4-BE49-F238E27FC236}">
-                <a16:creationId xmlns:a16="http://schemas.microsoft.com/office/drawing/2014/main" id="{F4CF92E8-45B2-3C60-C05E-E1652A44DE5F}"/>
-              </a:ext>
-            </a:extLst>
-          </p:cNvPr>
+            <a:r>
+              <a:rPr lang="de-DE"/>
+              <a:t>Bild durch Klicken auf Symbol hinzufügen</a:t>
+            </a:r>
+            <a:endParaRPr lang="en-US" dirty="0"/>
+          </a:p>
+        </p:txBody>
+      </p:sp>
+      <p:sp>
+        <p:nvSpPr>
+          <p:cNvPr id="4" name="Text Placeholder 3"/>
           <p:cNvSpPr>
             <a:spLocks noGrp="1"/>
           </p:cNvSpPr>
@@ -2614,8 +2288,8 @@
         </p:nvSpPr>
         <p:spPr>
           <a:xfrm>
-            <a:off x="839788" y="2057400"/>
-            <a:ext cx="3932237" cy="3811588"/>
+            <a:off x="1586960" y="3456146"/>
+            <a:ext cx="7430802" cy="6402939"/>
           </a:xfrm>
         </p:spPr>
         <p:txBody>
@@ -2623,39 +2297,39 @@
           <a:lstStyle>
             <a:lvl1pPr marL="0" indent="0">
               <a:buNone/>
-              <a:defRPr sz="1600"/>
+              <a:defRPr sz="2688"/>
             </a:lvl1pPr>
-            <a:lvl2pPr marL="457200" indent="0">
-              <a:buNone/>
-              <a:defRPr sz="1400"/>
+            <a:lvl2pPr marL="768050" indent="0">
+              <a:buNone/>
+              <a:defRPr sz="2352"/>
             </a:lvl2pPr>
-            <a:lvl3pPr marL="914400" indent="0">
-              <a:buNone/>
-              <a:defRPr sz="1200"/>
+            <a:lvl3pPr marL="1536101" indent="0">
+              <a:buNone/>
+              <a:defRPr sz="2016"/>
             </a:lvl3pPr>
-            <a:lvl4pPr marL="1371600" indent="0">
-              <a:buNone/>
-              <a:defRPr sz="1000"/>
+            <a:lvl4pPr marL="2304151" indent="0">
+              <a:buNone/>
+              <a:defRPr sz="1680"/>
             </a:lvl4pPr>
-            <a:lvl5pPr marL="1828800" indent="0">
-              <a:buNone/>
-              <a:defRPr sz="1000"/>
+            <a:lvl5pPr marL="3072201" indent="0">
+              <a:buNone/>
+              <a:defRPr sz="1680"/>
             </a:lvl5pPr>
-            <a:lvl6pPr marL="2286000" indent="0">
-              <a:buNone/>
-              <a:defRPr sz="1000"/>
+            <a:lvl6pPr marL="3840251" indent="0">
+              <a:buNone/>
+              <a:defRPr sz="1680"/>
             </a:lvl6pPr>
-            <a:lvl7pPr marL="2743200" indent="0">
-              <a:buNone/>
-              <a:defRPr sz="1000"/>
+            <a:lvl7pPr marL="4608302" indent="0">
+              <a:buNone/>
+              <a:defRPr sz="1680"/>
             </a:lvl7pPr>
-            <a:lvl8pPr marL="3200400" indent="0">
-              <a:buNone/>
-              <a:defRPr sz="1000"/>
+            <a:lvl8pPr marL="5376352" indent="0">
+              <a:buNone/>
+              <a:defRPr sz="1680"/>
             </a:lvl8pPr>
-            <a:lvl9pPr marL="3657600" indent="0">
-              <a:buNone/>
-              <a:defRPr sz="1000"/>
+            <a:lvl9pPr marL="6144402" indent="0">
+              <a:buNone/>
+              <a:defRPr sz="1680"/>
             </a:lvl9pPr>
           </a:lstStyle>
           <a:p>
@@ -2669,13 +2343,7 @@
       </p:sp>
       <p:sp>
         <p:nvSpPr>
-          <p:cNvPr id="5" name="Datumsplatzhalter 4">
-            <a:extLst>
-              <a:ext uri="{FF2B5EF4-FFF2-40B4-BE49-F238E27FC236}">
-                <a16:creationId xmlns:a16="http://schemas.microsoft.com/office/drawing/2014/main" id="{D35FD0EE-A41E-8B37-330E-C3BDFE047823}"/>
-              </a:ext>
-            </a:extLst>
-          </p:cNvPr>
+          <p:cNvPr id="5" name="Date Placeholder 4"/>
           <p:cNvSpPr>
             <a:spLocks noGrp="1"/>
           </p:cNvSpPr>
@@ -2690,7 +2358,7 @@
           <a:p>
             <a:fld id="{18BF9560-8671-453D-AEEB-6496BE150E94}" type="datetimeFigureOut">
               <a:rPr lang="de-CH" smtClean="0"/>
-              <a:t>21.12.2025</a:t>
+              <a:t>02.06.2026</a:t>
             </a:fld>
             <a:endParaRPr lang="de-CH"/>
           </a:p>
@@ -2698,13 +2366,7 @@
       </p:sp>
       <p:sp>
         <p:nvSpPr>
-          <p:cNvPr id="6" name="Fußzeilenplatzhalter 5">
-            <a:extLst>
-              <a:ext uri="{FF2B5EF4-FFF2-40B4-BE49-F238E27FC236}">
-                <a16:creationId xmlns:a16="http://schemas.microsoft.com/office/drawing/2014/main" id="{F4846CCA-93DB-60EA-B76F-C20D00E81F9C}"/>
-              </a:ext>
-            </a:extLst>
-          </p:cNvPr>
+          <p:cNvPr id="6" name="Footer Placeholder 5"/>
           <p:cNvSpPr>
             <a:spLocks noGrp="1"/>
           </p:cNvSpPr>
@@ -2723,13 +2385,7 @@
       </p:sp>
       <p:sp>
         <p:nvSpPr>
-          <p:cNvPr id="7" name="Foliennummernplatzhalter 6">
-            <a:extLst>
-              <a:ext uri="{FF2B5EF4-FFF2-40B4-BE49-F238E27FC236}">
-                <a16:creationId xmlns:a16="http://schemas.microsoft.com/office/drawing/2014/main" id="{D3431ACF-8E42-DD04-B05A-BC5BEF08E80A}"/>
-              </a:ext>
-            </a:extLst>
-          </p:cNvPr>
+          <p:cNvPr id="7" name="Slide Number Placeholder 6"/>
           <p:cNvSpPr>
             <a:spLocks noGrp="1"/>
           </p:cNvSpPr>
@@ -2753,7 +2409,7 @@
     </p:spTree>
     <p:extLst>
       <p:ext uri="{BB962C8B-B14F-4D97-AF65-F5344CB8AC3E}">
-        <p14:creationId xmlns:p14="http://schemas.microsoft.com/office/powerpoint/2010/main" val="2007438090"/>
+        <p14:creationId xmlns:p14="http://schemas.microsoft.com/office/powerpoint/2010/main" val="4002555126"/>
       </p:ext>
     </p:extLst>
   </p:cSld>
@@ -2787,13 +2443,7 @@
       </p:grpSpPr>
       <p:sp>
         <p:nvSpPr>
-          <p:cNvPr id="2" name="Titelplatzhalter 1">
-            <a:extLst>
-              <a:ext uri="{FF2B5EF4-FFF2-40B4-BE49-F238E27FC236}">
-                <a16:creationId xmlns:a16="http://schemas.microsoft.com/office/drawing/2014/main" id="{5EBF5863-1D80-08DA-FD08-C9E0C3E88067}"/>
-              </a:ext>
-            </a:extLst>
-          </p:cNvPr>
+          <p:cNvPr id="2" name="Title Placeholder 1"/>
           <p:cNvSpPr>
             <a:spLocks noGrp="1"/>
           </p:cNvSpPr>
@@ -2803,8 +2453,8 @@
         </p:nvSpPr>
         <p:spPr>
           <a:xfrm>
-            <a:off x="838200" y="365125"/>
-            <a:ext cx="10515600" cy="1325563"/>
+            <a:off x="1583958" y="613360"/>
+            <a:ext cx="19871472" cy="2226762"/>
           </a:xfrm>
           <a:prstGeom prst="rect">
             <a:avLst/>
@@ -2820,19 +2470,13 @@
               <a:rPr lang="de-DE"/>
               <a:t>Mastertitelformat bearbeiten</a:t>
             </a:r>
-            <a:endParaRPr lang="de-CH"/>
-          </a:p>
-        </p:txBody>
-      </p:sp>
-      <p:sp>
-        <p:nvSpPr>
-          <p:cNvPr id="3" name="Textplatzhalter 2">
-            <a:extLst>
-              <a:ext uri="{FF2B5EF4-FFF2-40B4-BE49-F238E27FC236}">
-                <a16:creationId xmlns:a16="http://schemas.microsoft.com/office/drawing/2014/main" id="{0A422A03-0EF5-FAA8-01A8-1BFFD79B7678}"/>
-              </a:ext>
-            </a:extLst>
-          </p:cNvPr>
+            <a:endParaRPr lang="en-US" dirty="0"/>
+          </a:p>
+        </p:txBody>
+      </p:sp>
+      <p:sp>
+        <p:nvSpPr>
+          <p:cNvPr id="3" name="Text Placeholder 2"/>
           <p:cNvSpPr>
             <a:spLocks noGrp="1"/>
           </p:cNvSpPr>
@@ -2842,8 +2486,8 @@
         </p:nvSpPr>
         <p:spPr>
           <a:xfrm>
-            <a:off x="838200" y="1825625"/>
-            <a:ext cx="10515600" cy="4351338"/>
+            <a:off x="1583958" y="3066796"/>
+            <a:ext cx="19871472" cy="7309644"/>
           </a:xfrm>
           <a:prstGeom prst="rect">
             <a:avLst/>
@@ -2888,19 +2532,13 @@
               <a:rPr lang="de-DE"/>
               <a:t>Fünfte Ebene</a:t>
             </a:r>
-            <a:endParaRPr lang="de-CH"/>
-          </a:p>
-        </p:txBody>
-      </p:sp>
-      <p:sp>
-        <p:nvSpPr>
-          <p:cNvPr id="4" name="Datumsplatzhalter 3">
-            <a:extLst>
-              <a:ext uri="{FF2B5EF4-FFF2-40B4-BE49-F238E27FC236}">
-                <a16:creationId xmlns:a16="http://schemas.microsoft.com/office/drawing/2014/main" id="{90CB4ECB-20AA-769A-0AD8-9A3F8603875E}"/>
-              </a:ext>
-            </a:extLst>
-          </p:cNvPr>
+            <a:endParaRPr lang="en-US" dirty="0"/>
+          </a:p>
+        </p:txBody>
+      </p:sp>
+      <p:sp>
+        <p:nvSpPr>
+          <p:cNvPr id="4" name="Date Placeholder 3"/>
           <p:cNvSpPr>
             <a:spLocks noGrp="1"/>
           </p:cNvSpPr>
@@ -2910,8 +2548,8 @@
         </p:nvSpPr>
         <p:spPr>
           <a:xfrm>
-            <a:off x="838200" y="6356350"/>
-            <a:ext cx="2743200" cy="365125"/>
+            <a:off x="1583958" y="10677787"/>
+            <a:ext cx="5183862" cy="613359"/>
           </a:xfrm>
           <a:prstGeom prst="rect">
             <a:avLst/>
@@ -2921,7 +2559,7 @@
           <a:bodyPr vert="horz" lIns="91440" tIns="45720" rIns="91440" bIns="45720" rtlCol="0" anchor="ctr"/>
           <a:lstStyle>
             <a:lvl1pPr algn="l">
-              <a:defRPr sz="1200">
+              <a:defRPr sz="2016">
                 <a:solidFill>
                   <a:schemeClr val="tx1">
                     <a:tint val="82000"/>
@@ -2933,7 +2571,7 @@
           <a:p>
             <a:fld id="{18BF9560-8671-453D-AEEB-6496BE150E94}" type="datetimeFigureOut">
               <a:rPr lang="de-CH" smtClean="0"/>
-              <a:t>21.12.2025</a:t>
+              <a:t>02.06.2026</a:t>
             </a:fld>
             <a:endParaRPr lang="de-CH"/>
           </a:p>
@@ -2941,13 +2579,7 @@
       </p:sp>
       <p:sp>
         <p:nvSpPr>
-          <p:cNvPr id="5" name="Fußzeilenplatzhalter 4">
-            <a:extLst>
-              <a:ext uri="{FF2B5EF4-FFF2-40B4-BE49-F238E27FC236}">
-                <a16:creationId xmlns:a16="http://schemas.microsoft.com/office/drawing/2014/main" id="{7FEF48F4-DF02-7833-8987-8B2915928F7E}"/>
-              </a:ext>
-            </a:extLst>
-          </p:cNvPr>
+          <p:cNvPr id="5" name="Footer Placeholder 4"/>
           <p:cNvSpPr>
             <a:spLocks noGrp="1"/>
           </p:cNvSpPr>
@@ -2957,8 +2589,8 @@
         </p:nvSpPr>
         <p:spPr>
           <a:xfrm>
-            <a:off x="4038600" y="6356350"/>
-            <a:ext cx="4114800" cy="365125"/>
+            <a:off x="7631798" y="10677787"/>
+            <a:ext cx="7775793" cy="613359"/>
           </a:xfrm>
           <a:prstGeom prst="rect">
             <a:avLst/>
@@ -2968,7 +2600,7 @@
           <a:bodyPr vert="horz" lIns="91440" tIns="45720" rIns="91440" bIns="45720" rtlCol="0" anchor="ctr"/>
           <a:lstStyle>
             <a:lvl1pPr algn="ctr">
-              <a:defRPr sz="1200">
+              <a:defRPr sz="2016">
                 <a:solidFill>
                   <a:schemeClr val="tx1">
                     <a:tint val="82000"/>
@@ -2984,13 +2616,7 @@
       </p:sp>
       <p:sp>
         <p:nvSpPr>
-          <p:cNvPr id="6" name="Foliennummernplatzhalter 5">
-            <a:extLst>
-              <a:ext uri="{FF2B5EF4-FFF2-40B4-BE49-F238E27FC236}">
-                <a16:creationId xmlns:a16="http://schemas.microsoft.com/office/drawing/2014/main" id="{4F5B37D6-CC4A-0C5B-8E5A-72933C3410D1}"/>
-              </a:ext>
-            </a:extLst>
-          </p:cNvPr>
+          <p:cNvPr id="6" name="Slide Number Placeholder 5"/>
           <p:cNvSpPr>
             <a:spLocks noGrp="1"/>
           </p:cNvSpPr>
@@ -3000,8 +2626,8 @@
         </p:nvSpPr>
         <p:spPr>
           <a:xfrm>
-            <a:off x="8610600" y="6356350"/>
-            <a:ext cx="2743200" cy="365125"/>
+            <a:off x="16271568" y="10677787"/>
+            <a:ext cx="5183862" cy="613359"/>
           </a:xfrm>
           <a:prstGeom prst="rect">
             <a:avLst/>
@@ -3011,7 +2637,7 @@
           <a:bodyPr vert="horz" lIns="91440" tIns="45720" rIns="91440" bIns="45720" rtlCol="0" anchor="ctr"/>
           <a:lstStyle>
             <a:lvl1pPr algn="r">
-              <a:defRPr sz="1200">
+              <a:defRPr sz="2016">
                 <a:solidFill>
                   <a:schemeClr val="tx1">
                     <a:tint val="82000"/>
@@ -3032,27 +2658,27 @@
     </p:spTree>
     <p:extLst>
       <p:ext uri="{BB962C8B-B14F-4D97-AF65-F5344CB8AC3E}">
-        <p14:creationId xmlns:p14="http://schemas.microsoft.com/office/powerpoint/2010/main" val="3522917949"/>
+        <p14:creationId xmlns:p14="http://schemas.microsoft.com/office/powerpoint/2010/main" val="32807293"/>
       </p:ext>
     </p:extLst>
   </p:cSld>
   <p:clrMap bg1="lt1" tx1="dk1" bg2="lt2" tx2="dk2" accent1="accent1" accent2="accent2" accent3="accent3" accent4="accent4" accent5="accent5" accent6="accent6" hlink="hlink" folHlink="folHlink"/>
   <p:sldLayoutIdLst>
-    <p:sldLayoutId id="2147483649" r:id="rId1"/>
-    <p:sldLayoutId id="2147483650" r:id="rId2"/>
-    <p:sldLayoutId id="2147483651" r:id="rId3"/>
-    <p:sldLayoutId id="2147483652" r:id="rId4"/>
-    <p:sldLayoutId id="2147483653" r:id="rId5"/>
-    <p:sldLayoutId id="2147483654" r:id="rId6"/>
-    <p:sldLayoutId id="2147483655" r:id="rId7"/>
-    <p:sldLayoutId id="2147483656" r:id="rId8"/>
-    <p:sldLayoutId id="2147483657" r:id="rId9"/>
-    <p:sldLayoutId id="2147483658" r:id="rId10"/>
-    <p:sldLayoutId id="2147483659" r:id="rId11"/>
+    <p:sldLayoutId id="2147483661" r:id="rId1"/>
+    <p:sldLayoutId id="2147483662" r:id="rId2"/>
+    <p:sldLayoutId id="2147483663" r:id="rId3"/>
+    <p:sldLayoutId id="2147483664" r:id="rId4"/>
+    <p:sldLayoutId id="2147483665" r:id="rId5"/>
+    <p:sldLayoutId id="2147483666" r:id="rId6"/>
+    <p:sldLayoutId id="2147483667" r:id="rId7"/>
+    <p:sldLayoutId id="2147483668" r:id="rId8"/>
+    <p:sldLayoutId id="2147483669" r:id="rId9"/>
+    <p:sldLayoutId id="2147483670" r:id="rId10"/>
+    <p:sldLayoutId id="2147483671" r:id="rId11"/>
   </p:sldLayoutIdLst>
   <p:txStyles>
     <p:titleStyle>
-      <a:lvl1pPr algn="l" defTabSz="914400" rtl="0" eaLnBrk="1" latinLnBrk="0" hangingPunct="1">
+      <a:lvl1pPr algn="l" defTabSz="1536101" rtl="0" eaLnBrk="1" latinLnBrk="0" hangingPunct="1">
         <a:lnSpc>
           <a:spcPct val="90000"/>
         </a:lnSpc>
@@ -3060,7 +2686,7 @@
           <a:spcPct val="0"/>
         </a:spcBef>
         <a:buNone/>
-        <a:defRPr sz="4400" kern="1200">
+        <a:defRPr sz="7392" kern="1200">
           <a:solidFill>
             <a:schemeClr val="tx1"/>
           </a:solidFill>
@@ -3071,16 +2697,16 @@
       </a:lvl1pPr>
     </p:titleStyle>
     <p:bodyStyle>
-      <a:lvl1pPr marL="228600" indent="-228600" algn="l" defTabSz="914400" rtl="0" eaLnBrk="1" latinLnBrk="0" hangingPunct="1">
+      <a:lvl1pPr marL="384025" indent="-384025" algn="l" defTabSz="1536101" rtl="0" eaLnBrk="1" latinLnBrk="0" hangingPunct="1">
         <a:lnSpc>
           <a:spcPct val="90000"/>
         </a:lnSpc>
         <a:spcBef>
-          <a:spcPts val="1000"/>
+          <a:spcPts val="1680"/>
         </a:spcBef>
         <a:buFont typeface="Arial" panose="020B0604020202020204" pitchFamily="34" charset="0"/>
         <a:buChar char="•"/>
-        <a:defRPr sz="2800" kern="1200">
+        <a:defRPr sz="4704" kern="1200">
           <a:solidFill>
             <a:schemeClr val="tx1"/>
           </a:solidFill>
@@ -3089,16 +2715,16 @@
           <a:cs typeface="+mn-cs"/>
         </a:defRPr>
       </a:lvl1pPr>
-      <a:lvl2pPr marL="685800" indent="-228600" algn="l" defTabSz="914400" rtl="0" eaLnBrk="1" latinLnBrk="0" hangingPunct="1">
+      <a:lvl2pPr marL="1152075" indent="-384025" algn="l" defTabSz="1536101" rtl="0" eaLnBrk="1" latinLnBrk="0" hangingPunct="1">
         <a:lnSpc>
           <a:spcPct val="90000"/>
         </a:lnSpc>
         <a:spcBef>
-          <a:spcPts val="500"/>
+          <a:spcPts val="840"/>
         </a:spcBef>
         <a:buFont typeface="Arial" panose="020B0604020202020204" pitchFamily="34" charset="0"/>
         <a:buChar char="•"/>
-        <a:defRPr sz="2400" kern="1200">
+        <a:defRPr sz="4032" kern="1200">
           <a:solidFill>
             <a:schemeClr val="tx1"/>
           </a:solidFill>
@@ -3107,16 +2733,16 @@
           <a:cs typeface="+mn-cs"/>
         </a:defRPr>
       </a:lvl2pPr>
-      <a:lvl3pPr marL="1143000" indent="-228600" algn="l" defTabSz="914400" rtl="0" eaLnBrk="1" latinLnBrk="0" hangingPunct="1">
+      <a:lvl3pPr marL="1920126" indent="-384025" algn="l" defTabSz="1536101" rtl="0" eaLnBrk="1" latinLnBrk="0" hangingPunct="1">
         <a:lnSpc>
           <a:spcPct val="90000"/>
         </a:lnSpc>
         <a:spcBef>
-          <a:spcPts val="500"/>
+          <a:spcPts val="840"/>
         </a:spcBef>
         <a:buFont typeface="Arial" panose="020B0604020202020204" pitchFamily="34" charset="0"/>
         <a:buChar char="•"/>
-        <a:defRPr sz="2000" kern="1200">
+        <a:defRPr sz="3360" kern="1200">
           <a:solidFill>
             <a:schemeClr val="tx1"/>
           </a:solidFill>
@@ -3125,16 +2751,16 @@
           <a:cs typeface="+mn-cs"/>
         </a:defRPr>
       </a:lvl3pPr>
-      <a:lvl4pPr marL="1600200" indent="-228600" algn="l" defTabSz="914400" rtl="0" eaLnBrk="1" latinLnBrk="0" hangingPunct="1">
+      <a:lvl4pPr marL="2688176" indent="-384025" algn="l" defTabSz="1536101" rtl="0" eaLnBrk="1" latinLnBrk="0" hangingPunct="1">
         <a:lnSpc>
           <a:spcPct val="90000"/>
         </a:lnSpc>
         <a:spcBef>
-          <a:spcPts val="500"/>
+          <a:spcPts val="840"/>
         </a:spcBef>
         <a:buFont typeface="Arial" panose="020B0604020202020204" pitchFamily="34" charset="0"/>
         <a:buChar char="•"/>
-        <a:defRPr sz="1800" kern="1200">
+        <a:defRPr sz="3024" kern="1200">
           <a:solidFill>
             <a:schemeClr val="tx1"/>
           </a:solidFill>
@@ -3143,16 +2769,16 @@
           <a:cs typeface="+mn-cs"/>
         </a:defRPr>
       </a:lvl4pPr>
-      <a:lvl5pPr marL="2057400" indent="-228600" algn="l" defTabSz="914400" rtl="0" eaLnBrk="1" latinLnBrk="0" hangingPunct="1">
+      <a:lvl5pPr marL="3456226" indent="-384025" algn="l" defTabSz="1536101" rtl="0" eaLnBrk="1" latinLnBrk="0" hangingPunct="1">
         <a:lnSpc>
           <a:spcPct val="90000"/>
         </a:lnSpc>
         <a:spcBef>
-          <a:spcPts val="500"/>
+          <a:spcPts val="840"/>
         </a:spcBef>
         <a:buFont typeface="Arial" panose="020B0604020202020204" pitchFamily="34" charset="0"/>
         <a:buChar char="•"/>
-        <a:defRPr sz="1800" kern="1200">
+        <a:defRPr sz="3024" kern="1200">
           <a:solidFill>
             <a:schemeClr val="tx1"/>
           </a:solidFill>
@@ -3161,16 +2787,16 @@
           <a:cs typeface="+mn-cs"/>
         </a:defRPr>
       </a:lvl5pPr>
-      <a:lvl6pPr marL="2514600" indent="-228600" algn="l" defTabSz="914400" rtl="0" eaLnBrk="1" latinLnBrk="0" hangingPunct="1">
+      <a:lvl6pPr marL="4224277" indent="-384025" algn="l" defTabSz="1536101" rtl="0" eaLnBrk="1" latinLnBrk="0" hangingPunct="1">
         <a:lnSpc>
           <a:spcPct val="90000"/>
         </a:lnSpc>
         <a:spcBef>
-          <a:spcPts val="500"/>
+          <a:spcPts val="840"/>
         </a:spcBef>
         <a:buFont typeface="Arial" panose="020B0604020202020204" pitchFamily="34" charset="0"/>
         <a:buChar char="•"/>
-        <a:defRPr sz="1800" kern="1200">
+        <a:defRPr sz="3024" kern="1200">
           <a:solidFill>
             <a:schemeClr val="tx1"/>
           </a:solidFill>
@@ -3179,16 +2805,16 @@
           <a:cs typeface="+mn-cs"/>
         </a:defRPr>
       </a:lvl6pPr>
-      <a:lvl7pPr marL="2971800" indent="-228600" algn="l" defTabSz="914400" rtl="0" eaLnBrk="1" latinLnBrk="0" hangingPunct="1">
+      <a:lvl7pPr marL="4992327" indent="-384025" algn="l" defTabSz="1536101" rtl="0" eaLnBrk="1" latinLnBrk="0" hangingPunct="1">
         <a:lnSpc>
           <a:spcPct val="90000"/>
         </a:lnSpc>
         <a:spcBef>
-          <a:spcPts val="500"/>
+          <a:spcPts val="840"/>
         </a:spcBef>
         <a:buFont typeface="Arial" panose="020B0604020202020204" pitchFamily="34" charset="0"/>
         <a:buChar char="•"/>
-        <a:defRPr sz="1800" kern="1200">
+        <a:defRPr sz="3024" kern="1200">
           <a:solidFill>
             <a:schemeClr val="tx1"/>
           </a:solidFill>
@@ -3197,16 +2823,16 @@
           <a:cs typeface="+mn-cs"/>
         </a:defRPr>
       </a:lvl7pPr>
-      <a:lvl8pPr marL="3429000" indent="-228600" algn="l" defTabSz="914400" rtl="0" eaLnBrk="1" latinLnBrk="0" hangingPunct="1">
+      <a:lvl8pPr marL="5760377" indent="-384025" algn="l" defTabSz="1536101" rtl="0" eaLnBrk="1" latinLnBrk="0" hangingPunct="1">
         <a:lnSpc>
           <a:spcPct val="90000"/>
         </a:lnSpc>
         <a:spcBef>
-          <a:spcPts val="500"/>
+          <a:spcPts val="840"/>
         </a:spcBef>
         <a:buFont typeface="Arial" panose="020B0604020202020204" pitchFamily="34" charset="0"/>
         <a:buChar char="•"/>
-        <a:defRPr sz="1800" kern="1200">
+        <a:defRPr sz="3024" kern="1200">
           <a:solidFill>
             <a:schemeClr val="tx1"/>
           </a:solidFill>
@@ -3215,16 +2841,16 @@
           <a:cs typeface="+mn-cs"/>
         </a:defRPr>
       </a:lvl8pPr>
-      <a:lvl9pPr marL="3886200" indent="-228600" algn="l" defTabSz="914400" rtl="0" eaLnBrk="1" latinLnBrk="0" hangingPunct="1">
+      <a:lvl9pPr marL="6528427" indent="-384025" algn="l" defTabSz="1536101" rtl="0" eaLnBrk="1" latinLnBrk="0" hangingPunct="1">
         <a:lnSpc>
           <a:spcPct val="90000"/>
         </a:lnSpc>
         <a:spcBef>
-          <a:spcPts val="500"/>
+          <a:spcPts val="840"/>
         </a:spcBef>
         <a:buFont typeface="Arial" panose="020B0604020202020204" pitchFamily="34" charset="0"/>
         <a:buChar char="•"/>
-        <a:defRPr sz="1800" kern="1200">
+        <a:defRPr sz="3024" kern="1200">
           <a:solidFill>
             <a:schemeClr val="tx1"/>
           </a:solidFill>
@@ -3236,10 +2862,10 @@
     </p:bodyStyle>
     <p:otherStyle>
       <a:defPPr>
-        <a:defRPr lang="de-DE"/>
+        <a:defRPr lang="en-US"/>
       </a:defPPr>
-      <a:lvl1pPr marL="0" algn="l" defTabSz="914400" rtl="0" eaLnBrk="1" latinLnBrk="0" hangingPunct="1">
-        <a:defRPr sz="1800" kern="1200">
+      <a:lvl1pPr marL="0" algn="l" defTabSz="1536101" rtl="0" eaLnBrk="1" latinLnBrk="0" hangingPunct="1">
+        <a:defRPr sz="3024" kern="1200">
           <a:solidFill>
             <a:schemeClr val="tx1"/>
           </a:solidFill>
@@ -3248,8 +2874,8 @@
           <a:cs typeface="+mn-cs"/>
         </a:defRPr>
       </a:lvl1pPr>
-      <a:lvl2pPr marL="457200" algn="l" defTabSz="914400" rtl="0" eaLnBrk="1" latinLnBrk="0" hangingPunct="1">
-        <a:defRPr sz="1800" kern="1200">
+      <a:lvl2pPr marL="768050" algn="l" defTabSz="1536101" rtl="0" eaLnBrk="1" latinLnBrk="0" hangingPunct="1">
+        <a:defRPr sz="3024" kern="1200">
           <a:solidFill>
             <a:schemeClr val="tx1"/>
           </a:solidFill>
@@ -3258,8 +2884,8 @@
           <a:cs typeface="+mn-cs"/>
         </a:defRPr>
       </a:lvl2pPr>
-      <a:lvl3pPr marL="914400" algn="l" defTabSz="914400" rtl="0" eaLnBrk="1" latinLnBrk="0" hangingPunct="1">
-        <a:defRPr sz="1800" kern="1200">
+      <a:lvl3pPr marL="1536101" algn="l" defTabSz="1536101" rtl="0" eaLnBrk="1" latinLnBrk="0" hangingPunct="1">
+        <a:defRPr sz="3024" kern="1200">
           <a:solidFill>
             <a:schemeClr val="tx1"/>
           </a:solidFill>
@@ -3268,8 +2894,8 @@
           <a:cs typeface="+mn-cs"/>
         </a:defRPr>
       </a:lvl3pPr>
-      <a:lvl4pPr marL="1371600" algn="l" defTabSz="914400" rtl="0" eaLnBrk="1" latinLnBrk="0" hangingPunct="1">
-        <a:defRPr sz="1800" kern="1200">
+      <a:lvl4pPr marL="2304151" algn="l" defTabSz="1536101" rtl="0" eaLnBrk="1" latinLnBrk="0" hangingPunct="1">
+        <a:defRPr sz="3024" kern="1200">
           <a:solidFill>
             <a:schemeClr val="tx1"/>
           </a:solidFill>
@@ -3278,8 +2904,8 @@
           <a:cs typeface="+mn-cs"/>
         </a:defRPr>
       </a:lvl4pPr>
-      <a:lvl5pPr marL="1828800" algn="l" defTabSz="914400" rtl="0" eaLnBrk="1" latinLnBrk="0" hangingPunct="1">
-        <a:defRPr sz="1800" kern="1200">
+      <a:lvl5pPr marL="3072201" algn="l" defTabSz="1536101" rtl="0" eaLnBrk="1" latinLnBrk="0" hangingPunct="1">
+        <a:defRPr sz="3024" kern="1200">
           <a:solidFill>
             <a:schemeClr val="tx1"/>
           </a:solidFill>
@@ -3288,8 +2914,8 @@
           <a:cs typeface="+mn-cs"/>
         </a:defRPr>
       </a:lvl5pPr>
-      <a:lvl6pPr marL="2286000" algn="l" defTabSz="914400" rtl="0" eaLnBrk="1" latinLnBrk="0" hangingPunct="1">
-        <a:defRPr sz="1800" kern="1200">
+      <a:lvl6pPr marL="3840251" algn="l" defTabSz="1536101" rtl="0" eaLnBrk="1" latinLnBrk="0" hangingPunct="1">
+        <a:defRPr sz="3024" kern="1200">
           <a:solidFill>
             <a:schemeClr val="tx1"/>
           </a:solidFill>
@@ -3298,8 +2924,8 @@
           <a:cs typeface="+mn-cs"/>
         </a:defRPr>
       </a:lvl6pPr>
-      <a:lvl7pPr marL="2743200" algn="l" defTabSz="914400" rtl="0" eaLnBrk="1" latinLnBrk="0" hangingPunct="1">
-        <a:defRPr sz="1800" kern="1200">
+      <a:lvl7pPr marL="4608302" algn="l" defTabSz="1536101" rtl="0" eaLnBrk="1" latinLnBrk="0" hangingPunct="1">
+        <a:defRPr sz="3024" kern="1200">
           <a:solidFill>
             <a:schemeClr val="tx1"/>
           </a:solidFill>
@@ -3308,8 +2934,8 @@
           <a:cs typeface="+mn-cs"/>
         </a:defRPr>
       </a:lvl7pPr>
-      <a:lvl8pPr marL="3200400" algn="l" defTabSz="914400" rtl="0" eaLnBrk="1" latinLnBrk="0" hangingPunct="1">
-        <a:defRPr sz="1800" kern="1200">
+      <a:lvl8pPr marL="5376352" algn="l" defTabSz="1536101" rtl="0" eaLnBrk="1" latinLnBrk="0" hangingPunct="1">
+        <a:defRPr sz="3024" kern="1200">
           <a:solidFill>
             <a:schemeClr val="tx1"/>
           </a:solidFill>
@@ -3318,8 +2944,8 @@
           <a:cs typeface="+mn-cs"/>
         </a:defRPr>
       </a:lvl8pPr>
-      <a:lvl9pPr marL="3657600" algn="l" defTabSz="914400" rtl="0" eaLnBrk="1" latinLnBrk="0" hangingPunct="1">
-        <a:defRPr sz="1800" kern="1200">
+      <a:lvl9pPr marL="6144402" algn="l" defTabSz="1536101" rtl="0" eaLnBrk="1" latinLnBrk="0" hangingPunct="1">
+        <a:defRPr sz="3024" kern="1200">
           <a:solidFill>
             <a:schemeClr val="tx1"/>
           </a:solidFill>
@@ -3368,7 +2994,7 @@
         </p:nvSpPr>
         <p:spPr>
           <a:xfrm>
-            <a:off x="1524000" y="1"/>
+            <a:off x="6947694" y="2331245"/>
             <a:ext cx="9144000" cy="2120348"/>
           </a:xfrm>
         </p:spPr>
@@ -3428,10 +3054,10 @@
           <p:nvPr/>
         </p:nvPicPr>
         <p:blipFill>
-          <a:blip r:embed="rId2">
+          <a:blip>
             <a:extLst>
               <a:ext uri="{96DAC541-7B7A-43D3-8B79-37D633B846F1}">
-                <asvg:svgBlip xmlns:asvg="http://schemas.microsoft.com/office/drawing/2016/SVG/main" r:embed="rId3"/>
+                <asvg:svgBlip xmlns:asvg="http://schemas.microsoft.com/office/drawing/2016/SVG/main" r:embed="rId2"/>
               </a:ext>
             </a:extLst>
           </a:blip>
@@ -3441,7 +3067,7 @@
         </p:blipFill>
         <p:spPr>
           <a:xfrm>
-            <a:off x="3538329" y="3255962"/>
+            <a:off x="8962023" y="5587206"/>
             <a:ext cx="914400" cy="914400"/>
           </a:xfrm>
           <a:prstGeom prst="rect">
@@ -3503,18 +3129,21 @@
         </p:nvSpPr>
         <p:spPr>
           <a:xfrm>
-            <a:off x="1524000" y="1"/>
-            <a:ext cx="9144000" cy="2120348"/>
+            <a:off x="3086176" y="-226290"/>
+            <a:ext cx="17161328" cy="4810822"/>
           </a:xfrm>
         </p:spPr>
         <p:txBody>
-          <a:bodyPr/>
-          <a:lstStyle/>
-          <a:p>
-            <a:r>
-              <a:rPr lang="de-CH" dirty="0"/>
+          <a:bodyPr>
+            <a:normAutofit/>
+          </a:bodyPr>
+          <a:lstStyle/>
+          <a:p>
+            <a:r>
+              <a:rPr lang="de-CH" sz="25100" dirty="0"/>
               <a:t>Willkommen</a:t>
             </a:r>
+            <a:endParaRPr lang="de-CH" dirty="0"/>
           </a:p>
         </p:txBody>
       </p:sp>
@@ -3534,15 +3163,21 @@
             <p:ph type="subTitle" idx="1"/>
           </p:nvPr>
         </p:nvSpPr>
-        <p:spPr/>
-        <p:txBody>
-          <a:bodyPr/>
-          <a:lstStyle/>
-          <a:p>
-            <a:r>
-              <a:rPr lang="de-CH" dirty="0"/>
+        <p:spPr>
+          <a:xfrm>
+            <a:off x="6947694" y="5213182"/>
+            <a:ext cx="9144000" cy="2375863"/>
+          </a:xfrm>
+        </p:spPr>
+        <p:txBody>
+          <a:bodyPr/>
+          <a:lstStyle/>
+          <a:p>
+            <a:r>
+              <a:rPr lang="de-CH" sz="6000" dirty="0"/>
               <a:t>Sponsoren</a:t>
             </a:r>
+            <a:endParaRPr lang="de-CH" dirty="0"/>
           </a:p>
         </p:txBody>
       </p:sp>
@@ -3575,8 +3210,8 @@
         </p:blipFill>
         <p:spPr bwMode="auto">
           <a:xfrm>
-            <a:off x="696775" y="4629150"/>
-            <a:ext cx="3629025" cy="1257300"/>
+            <a:off x="518989" y="6935957"/>
+            <a:ext cx="11000705" cy="3811267"/>
           </a:xfrm>
           <a:prstGeom prst="rect">
             <a:avLst/>
@@ -3595,10 +3230,10 @@
       </p:pic>
       <p:pic>
         <p:nvPicPr>
-          <p:cNvPr id="1028" name="Picture 4" descr="Kilchenmann AG in Kehrsatz ...">
+          <p:cNvPr id="4" name="Picture 2" descr="Berner Fachhochschule BFH | Bring Your ...">
             <a:extLst>
               <a:ext uri="{FF2B5EF4-FFF2-40B4-BE49-F238E27FC236}">
-                <a16:creationId xmlns:a16="http://schemas.microsoft.com/office/drawing/2014/main" id="{16C107E0-3EB8-3F67-6693-F09FEDFF5240}"/>
+                <a16:creationId xmlns:a16="http://schemas.microsoft.com/office/drawing/2014/main" id="{5AAF2711-E400-9E58-C80D-B32CB4EB222A}"/>
               </a:ext>
             </a:extLst>
           </p:cNvPr>
@@ -3608,7 +3243,7 @@
           <p:nvPr/>
         </p:nvPicPr>
         <p:blipFill>
-          <a:blip r:embed="rId3">
+          <a:blip r:embed="rId2">
             <a:extLst>
               <a:ext uri="{28A0092B-C50C-407E-A947-70E740481C1C}">
                 <a14:useLocalDpi xmlns:a14="http://schemas.microsoft.com/office/drawing/2010/main" val="0"/>
@@ -3622,8 +3257,8 @@
         </p:blipFill>
         <p:spPr bwMode="auto">
           <a:xfrm>
-            <a:off x="7929356" y="4952586"/>
-            <a:ext cx="3762375" cy="1219200"/>
+            <a:off x="11666840" y="6935957"/>
+            <a:ext cx="11000705" cy="3811267"/>
           </a:xfrm>
           <a:prstGeom prst="rect">
             <a:avLst/>
@@ -3658,9 +3293,15 @@
   <p:cSld>
     <p:bg>
       <p:bgPr>
-        <a:solidFill>
-          <a:schemeClr val="bg1"/>
-        </a:solidFill>
+        <a:blipFill dpi="0" rotWithShape="1">
+          <a:blip r:embed="rId2">
+            <a:lum/>
+          </a:blip>
+          <a:srcRect/>
+          <a:stretch>
+            <a:fillRect t="-6000" b="-6000"/>
+          </a:stretch>
+        </a:blipFill>
         <a:effectLst/>
       </p:bgPr>
     </p:bg>
@@ -3678,200 +3319,6 @@
           <a:chExt cx="0" cy="0"/>
         </a:xfrm>
       </p:grpSpPr>
-      <p:sp>
-        <p:nvSpPr>
-          <p:cNvPr id="10" name="Rectangle 9">
-            <a:extLst>
-              <a:ext uri="{FF2B5EF4-FFF2-40B4-BE49-F238E27FC236}">
-                <a16:creationId xmlns:a16="http://schemas.microsoft.com/office/drawing/2014/main" id="{42A4FC2C-047E-45A5-965D-8E1E3BF09BC6}"/>
-              </a:ext>
-              <a:ext uri="{C183D7F6-B498-43B3-948B-1728B52AA6E4}">
-                <adec:decorative xmlns:adec="http://schemas.microsoft.com/office/drawing/2017/decorative" val="1"/>
-              </a:ext>
-            </a:extLst>
-          </p:cNvPr>
-          <p:cNvSpPr>
-            <a:spLocks noGrp="1" noRot="1" noChangeAspect="1" noMove="1" noResize="1" noEditPoints="1" noAdjustHandles="1" noChangeArrowheads="1" noChangeShapeType="1" noTextEdit="1"/>
-          </p:cNvSpPr>
-          <p:nvPr>
-            <p:extLst>
-              <p:ext uri="{386F3935-93C4-4BCD-93E2-E3B085C9AB24}">
-                <p16:designElem xmlns:p16="http://schemas.microsoft.com/office/powerpoint/2015/main" val="1"/>
-              </p:ext>
-            </p:extLst>
-          </p:nvPr>
-        </p:nvSpPr>
-        <p:spPr bwMode="white">
-          <a:xfrm>
-            <a:off x="1524" y="0"/>
-            <a:ext cx="12188952" cy="6858000"/>
-          </a:xfrm>
-          <a:prstGeom prst="rect">
-            <a:avLst/>
-          </a:prstGeom>
-          <a:noFill/>
-          <a:ln>
-            <a:noFill/>
-          </a:ln>
-        </p:spPr>
-        <p:style>
-          <a:lnRef idx="2">
-            <a:schemeClr val="accent1">
-              <a:shade val="50000"/>
-            </a:schemeClr>
-          </a:lnRef>
-          <a:fillRef idx="1">
-            <a:schemeClr val="accent1"/>
-          </a:fillRef>
-          <a:effectRef idx="0">
-            <a:schemeClr val="accent1"/>
-          </a:effectRef>
-          <a:fontRef idx="minor">
-            <a:schemeClr val="lt1"/>
-          </a:fontRef>
-        </p:style>
-        <p:txBody>
-          <a:bodyPr rtlCol="0" anchor="ctr"/>
-          <a:lstStyle>
-            <a:defPPr>
-              <a:defRPr lang="en-US"/>
-            </a:defPPr>
-            <a:lvl1pPr marL="0" algn="l" defTabSz="914400" rtl="0" eaLnBrk="1" latinLnBrk="0" hangingPunct="1">
-              <a:defRPr sz="1800" kern="1200">
-                <a:solidFill>
-                  <a:schemeClr val="lt1"/>
-                </a:solidFill>
-                <a:latin typeface="+mn-lt"/>
-                <a:ea typeface="+mn-ea"/>
-                <a:cs typeface="+mn-cs"/>
-              </a:defRPr>
-            </a:lvl1pPr>
-            <a:lvl2pPr marL="457200" algn="l" defTabSz="914400" rtl="0" eaLnBrk="1" latinLnBrk="0" hangingPunct="1">
-              <a:defRPr sz="1800" kern="1200">
-                <a:solidFill>
-                  <a:schemeClr val="lt1"/>
-                </a:solidFill>
-                <a:latin typeface="+mn-lt"/>
-                <a:ea typeface="+mn-ea"/>
-                <a:cs typeface="+mn-cs"/>
-              </a:defRPr>
-            </a:lvl2pPr>
-            <a:lvl3pPr marL="914400" algn="l" defTabSz="914400" rtl="0" eaLnBrk="1" latinLnBrk="0" hangingPunct="1">
-              <a:defRPr sz="1800" kern="1200">
-                <a:solidFill>
-                  <a:schemeClr val="lt1"/>
-                </a:solidFill>
-                <a:latin typeface="+mn-lt"/>
-                <a:ea typeface="+mn-ea"/>
-                <a:cs typeface="+mn-cs"/>
-              </a:defRPr>
-            </a:lvl3pPr>
-            <a:lvl4pPr marL="1371600" algn="l" defTabSz="914400" rtl="0" eaLnBrk="1" latinLnBrk="0" hangingPunct="1">
-              <a:defRPr sz="1800" kern="1200">
-                <a:solidFill>
-                  <a:schemeClr val="lt1"/>
-                </a:solidFill>
-                <a:latin typeface="+mn-lt"/>
-                <a:ea typeface="+mn-ea"/>
-                <a:cs typeface="+mn-cs"/>
-              </a:defRPr>
-            </a:lvl4pPr>
-            <a:lvl5pPr marL="1828800" algn="l" defTabSz="914400" rtl="0" eaLnBrk="1" latinLnBrk="0" hangingPunct="1">
-              <a:defRPr sz="1800" kern="1200">
-                <a:solidFill>
-                  <a:schemeClr val="lt1"/>
-                </a:solidFill>
-                <a:latin typeface="+mn-lt"/>
-                <a:ea typeface="+mn-ea"/>
-                <a:cs typeface="+mn-cs"/>
-              </a:defRPr>
-            </a:lvl5pPr>
-            <a:lvl6pPr marL="2286000" algn="l" defTabSz="914400" rtl="0" eaLnBrk="1" latinLnBrk="0" hangingPunct="1">
-              <a:defRPr sz="1800" kern="1200">
-                <a:solidFill>
-                  <a:schemeClr val="lt1"/>
-                </a:solidFill>
-                <a:latin typeface="+mn-lt"/>
-                <a:ea typeface="+mn-ea"/>
-                <a:cs typeface="+mn-cs"/>
-              </a:defRPr>
-            </a:lvl6pPr>
-            <a:lvl7pPr marL="2743200" algn="l" defTabSz="914400" rtl="0" eaLnBrk="1" latinLnBrk="0" hangingPunct="1">
-              <a:defRPr sz="1800" kern="1200">
-                <a:solidFill>
-                  <a:schemeClr val="lt1"/>
-                </a:solidFill>
-                <a:latin typeface="+mn-lt"/>
-                <a:ea typeface="+mn-ea"/>
-                <a:cs typeface="+mn-cs"/>
-              </a:defRPr>
-            </a:lvl7pPr>
-            <a:lvl8pPr marL="3200400" algn="l" defTabSz="914400" rtl="0" eaLnBrk="1" latinLnBrk="0" hangingPunct="1">
-              <a:defRPr sz="1800" kern="1200">
-                <a:solidFill>
-                  <a:schemeClr val="lt1"/>
-                </a:solidFill>
-                <a:latin typeface="+mn-lt"/>
-                <a:ea typeface="+mn-ea"/>
-                <a:cs typeface="+mn-cs"/>
-              </a:defRPr>
-            </a:lvl8pPr>
-            <a:lvl9pPr marL="3657600" algn="l" defTabSz="914400" rtl="0" eaLnBrk="1" latinLnBrk="0" hangingPunct="1">
-              <a:defRPr sz="1800" kern="1200">
-                <a:solidFill>
-                  <a:schemeClr val="lt1"/>
-                </a:solidFill>
-                <a:latin typeface="+mn-lt"/>
-                <a:ea typeface="+mn-ea"/>
-                <a:cs typeface="+mn-cs"/>
-              </a:defRPr>
-            </a:lvl9pPr>
-          </a:lstStyle>
-          <a:p>
-            <a:pPr algn="ctr"/>
-            <a:endParaRPr lang="en-US"/>
-          </a:p>
-        </p:txBody>
-      </p:sp>
-      <p:pic>
-        <p:nvPicPr>
-          <p:cNvPr id="5" name="Inhaltsplatzhalter 4" descr="Eckflagge auf Fußballfeld">
-            <a:extLst>
-              <a:ext uri="{FF2B5EF4-FFF2-40B4-BE49-F238E27FC236}">
-                <a16:creationId xmlns:a16="http://schemas.microsoft.com/office/drawing/2014/main" id="{88CE92D6-5EA7-9026-6E86-BE2BA8A39D96}"/>
-              </a:ext>
-            </a:extLst>
-          </p:cNvPr>
-          <p:cNvPicPr>
-            <a:picLocks noGrp="1" noChangeAspect="1"/>
-          </p:cNvPicPr>
-          <p:nvPr>
-            <p:ph idx="1"/>
-          </p:nvPr>
-        </p:nvPicPr>
-        <p:blipFill>
-          <a:blip r:embed="rId2">
-            <a:extLst>
-              <a:ext uri="{28A0092B-C50C-407E-A947-70E740481C1C}">
-                <a14:useLocalDpi xmlns:a14="http://schemas.microsoft.com/office/drawing/2010/main" val="0"/>
-              </a:ext>
-            </a:extLst>
-          </a:blip>
-          <a:srcRect b="15746"/>
-          <a:stretch>
-            <a:fillRect/>
-          </a:stretch>
-        </p:blipFill>
-        <p:spPr>
-          <a:xfrm>
-            <a:off x="20" y="1282"/>
-            <a:ext cx="12191980" cy="6856718"/>
-          </a:xfrm>
-          <a:prstGeom prst="rect">
-            <a:avLst/>
-          </a:prstGeom>
-        </p:spPr>
-      </p:pic>
     </p:spTree>
     <p:extLst>
       <p:ext uri="{BB962C8B-B14F-4D97-AF65-F5344CB8AC3E}">
@@ -3910,161 +3357,6 @@
           <a:chExt cx="0" cy="0"/>
         </a:xfrm>
       </p:grpSpPr>
-      <p:sp>
-        <p:nvSpPr>
-          <p:cNvPr id="10" name="Rectangle 9">
-            <a:extLst>
-              <a:ext uri="{FF2B5EF4-FFF2-40B4-BE49-F238E27FC236}">
-                <a16:creationId xmlns:a16="http://schemas.microsoft.com/office/drawing/2014/main" id="{42A4FC2C-047E-45A5-965D-8E1E3BF09BC6}"/>
-              </a:ext>
-              <a:ext uri="{C183D7F6-B498-43B3-948B-1728B52AA6E4}">
-                <adec:decorative xmlns:adec="http://schemas.microsoft.com/office/drawing/2017/decorative" val="1"/>
-              </a:ext>
-            </a:extLst>
-          </p:cNvPr>
-          <p:cNvSpPr>
-            <a:spLocks noGrp="1" noRot="1" noChangeAspect="1" noMove="1" noResize="1" noEditPoints="1" noAdjustHandles="1" noChangeArrowheads="1" noChangeShapeType="1" noTextEdit="1"/>
-          </p:cNvSpPr>
-          <p:nvPr>
-            <p:extLst>
-              <p:ext uri="{386F3935-93C4-4BCD-93E2-E3B085C9AB24}">
-                <p16:designElem xmlns:p16="http://schemas.microsoft.com/office/powerpoint/2015/main" val="1"/>
-              </p:ext>
-            </p:extLst>
-          </p:nvPr>
-        </p:nvSpPr>
-        <p:spPr bwMode="white">
-          <a:xfrm>
-            <a:off x="1524" y="0"/>
-            <a:ext cx="12188952" cy="6858000"/>
-          </a:xfrm>
-          <a:prstGeom prst="rect">
-            <a:avLst/>
-          </a:prstGeom>
-          <a:noFill/>
-          <a:ln>
-            <a:noFill/>
-          </a:ln>
-        </p:spPr>
-        <p:style>
-          <a:lnRef idx="2">
-            <a:schemeClr val="accent1">
-              <a:shade val="50000"/>
-            </a:schemeClr>
-          </a:lnRef>
-          <a:fillRef idx="1">
-            <a:schemeClr val="accent1"/>
-          </a:fillRef>
-          <a:effectRef idx="0">
-            <a:schemeClr val="accent1"/>
-          </a:effectRef>
-          <a:fontRef idx="minor">
-            <a:schemeClr val="lt1"/>
-          </a:fontRef>
-        </p:style>
-        <p:txBody>
-          <a:bodyPr rtlCol="0" anchor="ctr"/>
-          <a:lstStyle>
-            <a:defPPr>
-              <a:defRPr lang="en-US"/>
-            </a:defPPr>
-            <a:lvl1pPr marL="0" algn="l" defTabSz="914400" rtl="0" eaLnBrk="1" latinLnBrk="0" hangingPunct="1">
-              <a:defRPr sz="1800" kern="1200">
-                <a:solidFill>
-                  <a:schemeClr val="lt1"/>
-                </a:solidFill>
-                <a:latin typeface="+mn-lt"/>
-                <a:ea typeface="+mn-ea"/>
-                <a:cs typeface="+mn-cs"/>
-              </a:defRPr>
-            </a:lvl1pPr>
-            <a:lvl2pPr marL="457200" algn="l" defTabSz="914400" rtl="0" eaLnBrk="1" latinLnBrk="0" hangingPunct="1">
-              <a:defRPr sz="1800" kern="1200">
-                <a:solidFill>
-                  <a:schemeClr val="lt1"/>
-                </a:solidFill>
-                <a:latin typeface="+mn-lt"/>
-                <a:ea typeface="+mn-ea"/>
-                <a:cs typeface="+mn-cs"/>
-              </a:defRPr>
-            </a:lvl2pPr>
-            <a:lvl3pPr marL="914400" algn="l" defTabSz="914400" rtl="0" eaLnBrk="1" latinLnBrk="0" hangingPunct="1">
-              <a:defRPr sz="1800" kern="1200">
-                <a:solidFill>
-                  <a:schemeClr val="lt1"/>
-                </a:solidFill>
-                <a:latin typeface="+mn-lt"/>
-                <a:ea typeface="+mn-ea"/>
-                <a:cs typeface="+mn-cs"/>
-              </a:defRPr>
-            </a:lvl3pPr>
-            <a:lvl4pPr marL="1371600" algn="l" defTabSz="914400" rtl="0" eaLnBrk="1" latinLnBrk="0" hangingPunct="1">
-              <a:defRPr sz="1800" kern="1200">
-                <a:solidFill>
-                  <a:schemeClr val="lt1"/>
-                </a:solidFill>
-                <a:latin typeface="+mn-lt"/>
-                <a:ea typeface="+mn-ea"/>
-                <a:cs typeface="+mn-cs"/>
-              </a:defRPr>
-            </a:lvl4pPr>
-            <a:lvl5pPr marL="1828800" algn="l" defTabSz="914400" rtl="0" eaLnBrk="1" latinLnBrk="0" hangingPunct="1">
-              <a:defRPr sz="1800" kern="1200">
-                <a:solidFill>
-                  <a:schemeClr val="lt1"/>
-                </a:solidFill>
-                <a:latin typeface="+mn-lt"/>
-                <a:ea typeface="+mn-ea"/>
-                <a:cs typeface="+mn-cs"/>
-              </a:defRPr>
-            </a:lvl5pPr>
-            <a:lvl6pPr marL="2286000" algn="l" defTabSz="914400" rtl="0" eaLnBrk="1" latinLnBrk="0" hangingPunct="1">
-              <a:defRPr sz="1800" kern="1200">
-                <a:solidFill>
-                  <a:schemeClr val="lt1"/>
-                </a:solidFill>
-                <a:latin typeface="+mn-lt"/>
-                <a:ea typeface="+mn-ea"/>
-                <a:cs typeface="+mn-cs"/>
-              </a:defRPr>
-            </a:lvl6pPr>
-            <a:lvl7pPr marL="2743200" algn="l" defTabSz="914400" rtl="0" eaLnBrk="1" latinLnBrk="0" hangingPunct="1">
-              <a:defRPr sz="1800" kern="1200">
-                <a:solidFill>
-                  <a:schemeClr val="lt1"/>
-                </a:solidFill>
-                <a:latin typeface="+mn-lt"/>
-                <a:ea typeface="+mn-ea"/>
-                <a:cs typeface="+mn-cs"/>
-              </a:defRPr>
-            </a:lvl7pPr>
-            <a:lvl8pPr marL="3200400" algn="l" defTabSz="914400" rtl="0" eaLnBrk="1" latinLnBrk="0" hangingPunct="1">
-              <a:defRPr sz="1800" kern="1200">
-                <a:solidFill>
-                  <a:schemeClr val="lt1"/>
-                </a:solidFill>
-                <a:latin typeface="+mn-lt"/>
-                <a:ea typeface="+mn-ea"/>
-                <a:cs typeface="+mn-cs"/>
-              </a:defRPr>
-            </a:lvl8pPr>
-            <a:lvl9pPr marL="3657600" algn="l" defTabSz="914400" rtl="0" eaLnBrk="1" latinLnBrk="0" hangingPunct="1">
-              <a:defRPr sz="1800" kern="1200">
-                <a:solidFill>
-                  <a:schemeClr val="lt1"/>
-                </a:solidFill>
-                <a:latin typeface="+mn-lt"/>
-                <a:ea typeface="+mn-ea"/>
-                <a:cs typeface="+mn-cs"/>
-              </a:defRPr>
-            </a:lvl9pPr>
-          </a:lstStyle>
-          <a:p>
-            <a:pPr algn="ctr"/>
-            <a:endParaRPr lang="en-US"/>
-          </a:p>
-        </p:txBody>
-      </p:sp>
       <p:pic>
         <p:nvPicPr>
           <p:cNvPr id="5" name="Inhaltsplatzhalter 4" descr="Ein Bild, das Sport, Gras, Person, Sportspiele enthält.&#10;&#10;KI-generierte Inhalte können fehlerhaft sein.">
@@ -4099,8 +3391,8 @@
         </p:blipFill>
         <p:spPr>
           <a:xfrm>
-            <a:off x="20" y="1282"/>
-            <a:ext cx="12191980" cy="6856718"/>
+            <a:off x="0" y="0"/>
+            <a:ext cx="23039388" cy="11561547"/>
           </a:xfrm>
           <a:prstGeom prst="rect">
             <a:avLst/>

</xml_diff>

<commit_message>
Slides has been updatet.
</commit_message>
<xml_diff>
--- a/slides/PreGame/Willkommen.pptx
+++ b/slides/PreGame/Willkommen.pptx
@@ -6,9 +6,10 @@
   </p:sldMasterIdLst>
   <p:sldIdLst>
     <p:sldId id="256" r:id="rId2"/>
-    <p:sldId id="257" r:id="rId3"/>
-    <p:sldId id="258" r:id="rId4"/>
+    <p:sldId id="258" r:id="rId3"/>
+    <p:sldId id="257" r:id="rId4"/>
     <p:sldId id="259" r:id="rId5"/>
+    <p:sldId id="260" r:id="rId6"/>
   </p:sldIdLst>
   <p:sldSz cx="23039388" cy="11520488"/>
   <p:notesSz cx="6858000" cy="9144000"/>
@@ -2978,39 +2979,6 @@
       </p:grpSpPr>
       <p:sp>
         <p:nvSpPr>
-          <p:cNvPr id="2" name="Titel 1">
-            <a:extLst>
-              <a:ext uri="{FF2B5EF4-FFF2-40B4-BE49-F238E27FC236}">
-                <a16:creationId xmlns:a16="http://schemas.microsoft.com/office/drawing/2014/main" id="{72AC92E2-6F98-132A-8AE9-DCE3FEAEE5E0}"/>
-              </a:ext>
-            </a:extLst>
-          </p:cNvPr>
-          <p:cNvSpPr>
-            <a:spLocks noGrp="1"/>
-          </p:cNvSpPr>
-          <p:nvPr>
-            <p:ph type="ctrTitle"/>
-          </p:nvPr>
-        </p:nvSpPr>
-        <p:spPr>
-          <a:xfrm>
-            <a:off x="6947694" y="2331245"/>
-            <a:ext cx="9144000" cy="2120348"/>
-          </a:xfrm>
-        </p:spPr>
-        <p:txBody>
-          <a:bodyPr/>
-          <a:lstStyle/>
-          <a:p>
-            <a:r>
-              <a:rPr lang="de-CH" dirty="0"/>
-              <a:t>Willkommen</a:t>
-            </a:r>
-          </a:p>
-        </p:txBody>
-      </p:sp>
-      <p:sp>
-        <p:nvSpPr>
           <p:cNvPr id="3" name="Untertitel 2">
             <a:extLst>
               <a:ext uri="{FF2B5EF4-FFF2-40B4-BE49-F238E27FC236}">
@@ -3025,23 +2993,83 @@
             <p:ph type="subTitle" idx="1"/>
           </p:nvPr>
         </p:nvSpPr>
-        <p:spPr/>
-        <p:txBody>
-          <a:bodyPr>
+        <p:spPr>
+          <a:xfrm>
+            <a:off x="3027069" y="4369519"/>
+            <a:ext cx="17279541" cy="2781450"/>
+          </a:xfrm>
+        </p:spPr>
+        <p:txBody>
+          <a:bodyPr anchor="ctr">
             <a:normAutofit/>
           </a:bodyPr>
           <a:lstStyle/>
           <a:p>
             <a:r>
-              <a:rPr lang="de-CH" sz="3200" b="1" dirty="0"/>
-              <a:t>Anpfiff: 15:30</a:t>
-            </a:r>
+              <a:rPr lang="de-CH" sz="8800" b="1" dirty="0"/>
+              <a:t>  Anpfiff: 15:30</a:t>
+            </a:r>
+          </a:p>
+        </p:txBody>
+      </p:sp>
+      <p:sp>
+        <p:nvSpPr>
+          <p:cNvPr id="4" name="Titel 1">
+            <a:extLst>
+              <a:ext uri="{FF2B5EF4-FFF2-40B4-BE49-F238E27FC236}">
+                <a16:creationId xmlns:a16="http://schemas.microsoft.com/office/drawing/2014/main" id="{53B735CD-9965-F21B-6808-E1D18440E41A}"/>
+              </a:ext>
+            </a:extLst>
+          </p:cNvPr>
+          <p:cNvSpPr txBox="1">
+            <a:spLocks/>
+          </p:cNvSpPr>
+          <p:nvPr/>
+        </p:nvSpPr>
+        <p:spPr>
+          <a:xfrm>
+            <a:off x="3086176" y="510638"/>
+            <a:ext cx="17161328" cy="4073893"/>
+          </a:xfrm>
+          <a:prstGeom prst="rect">
+            <a:avLst/>
+          </a:prstGeom>
+        </p:spPr>
+        <p:txBody>
+          <a:bodyPr vert="horz" lIns="91440" tIns="45720" rIns="91440" bIns="45720" rtlCol="0" anchor="t">
+            <a:noAutofit/>
+          </a:bodyPr>
+          <a:lstStyle>
+            <a:lvl1pPr algn="ctr" defTabSz="1536101" rtl="0" eaLnBrk="1" latinLnBrk="0" hangingPunct="1">
+              <a:lnSpc>
+                <a:spcPct val="90000"/>
+              </a:lnSpc>
+              <a:spcBef>
+                <a:spcPct val="0"/>
+              </a:spcBef>
+              <a:buNone/>
+              <a:defRPr sz="10079" kern="1200">
+                <a:solidFill>
+                  <a:schemeClr val="tx1"/>
+                </a:solidFill>
+                <a:latin typeface="+mj-lt"/>
+                <a:ea typeface="+mj-ea"/>
+                <a:cs typeface="+mj-cs"/>
+              </a:defRPr>
+            </a:lvl1pPr>
+          </a:lstStyle>
+          <a:p>
+            <a:r>
+              <a:rPr lang="de-CH" sz="13100"/>
+              <a:t>Herzlich Willkommen</a:t>
+            </a:r>
+            <a:endParaRPr lang="de-CH" sz="7200" dirty="0"/>
           </a:p>
         </p:txBody>
       </p:sp>
       <p:pic>
         <p:nvPicPr>
-          <p:cNvPr id="5" name="Grafik 4" descr="Pfiff mit einfarbiger Füllung">
+          <p:cNvPr id="8" name="Grafik 7" descr="Pfiff mit einfarbiger Füllung">
             <a:extLst>
               <a:ext uri="{FF2B5EF4-FFF2-40B4-BE49-F238E27FC236}">
                 <a16:creationId xmlns:a16="http://schemas.microsoft.com/office/drawing/2014/main" id="{B4A03DB3-8709-1631-5621-89A12F5DE91C}"/>
@@ -3067,8 +3095,8 @@
         </p:blipFill>
         <p:spPr>
           <a:xfrm>
-            <a:off x="8962023" y="5587206"/>
-            <a:ext cx="914400" cy="914400"/>
+            <a:off x="4342964" y="3238972"/>
+            <a:ext cx="4053333" cy="4053333"/>
           </a:xfrm>
           <a:prstGeom prst="rect">
             <a:avLst/>
@@ -3089,206 +3117,6 @@
 </file>
 
 <file path=ppt/slides/slide2.xml><?xml version="1.0" encoding="utf-8"?>
-<p:sld xmlns:a="http://schemas.openxmlformats.org/drawingml/2006/main" xmlns:r="http://schemas.openxmlformats.org/officeDocument/2006/relationships" xmlns:p="http://schemas.openxmlformats.org/presentationml/2006/main">
-  <p:cSld>
-    <p:spTree>
-      <p:nvGrpSpPr>
-        <p:cNvPr id="1" name="">
-          <a:extLst>
-            <a:ext uri="{FF2B5EF4-FFF2-40B4-BE49-F238E27FC236}">
-              <a16:creationId xmlns:a16="http://schemas.microsoft.com/office/drawing/2014/main" id="{1CC33409-F679-693A-B223-4BD2BB6E8B14}"/>
-            </a:ext>
-          </a:extLst>
-        </p:cNvPr>
-        <p:cNvGrpSpPr/>
-        <p:nvPr/>
-      </p:nvGrpSpPr>
-      <p:grpSpPr>
-        <a:xfrm>
-          <a:off x="0" y="0"/>
-          <a:ext cx="0" cy="0"/>
-          <a:chOff x="0" y="0"/>
-          <a:chExt cx="0" cy="0"/>
-        </a:xfrm>
-      </p:grpSpPr>
-      <p:sp>
-        <p:nvSpPr>
-          <p:cNvPr id="2" name="Titel 1">
-            <a:extLst>
-              <a:ext uri="{FF2B5EF4-FFF2-40B4-BE49-F238E27FC236}">
-                <a16:creationId xmlns:a16="http://schemas.microsoft.com/office/drawing/2014/main" id="{C8DDFFD1-77B5-D83C-F7EC-C5377D0FF024}"/>
-              </a:ext>
-            </a:extLst>
-          </p:cNvPr>
-          <p:cNvSpPr>
-            <a:spLocks noGrp="1"/>
-          </p:cNvSpPr>
-          <p:nvPr>
-            <p:ph type="ctrTitle"/>
-          </p:nvPr>
-        </p:nvSpPr>
-        <p:spPr>
-          <a:xfrm>
-            <a:off x="3086176" y="-226290"/>
-            <a:ext cx="17161328" cy="4810822"/>
-          </a:xfrm>
-        </p:spPr>
-        <p:txBody>
-          <a:bodyPr>
-            <a:normAutofit/>
-          </a:bodyPr>
-          <a:lstStyle/>
-          <a:p>
-            <a:r>
-              <a:rPr lang="de-CH" sz="25100" dirty="0"/>
-              <a:t>Willkommen</a:t>
-            </a:r>
-            <a:endParaRPr lang="de-CH" dirty="0"/>
-          </a:p>
-        </p:txBody>
-      </p:sp>
-      <p:sp>
-        <p:nvSpPr>
-          <p:cNvPr id="3" name="Untertitel 2">
-            <a:extLst>
-              <a:ext uri="{FF2B5EF4-FFF2-40B4-BE49-F238E27FC236}">
-                <a16:creationId xmlns:a16="http://schemas.microsoft.com/office/drawing/2014/main" id="{A68D77BB-1357-59BA-76D6-22551424AF62}"/>
-              </a:ext>
-            </a:extLst>
-          </p:cNvPr>
-          <p:cNvSpPr>
-            <a:spLocks noGrp="1"/>
-          </p:cNvSpPr>
-          <p:nvPr>
-            <p:ph type="subTitle" idx="1"/>
-          </p:nvPr>
-        </p:nvSpPr>
-        <p:spPr>
-          <a:xfrm>
-            <a:off x="6947694" y="5213182"/>
-            <a:ext cx="9144000" cy="2375863"/>
-          </a:xfrm>
-        </p:spPr>
-        <p:txBody>
-          <a:bodyPr/>
-          <a:lstStyle/>
-          <a:p>
-            <a:r>
-              <a:rPr lang="de-CH" sz="6000" dirty="0"/>
-              <a:t>Sponsoren</a:t>
-            </a:r>
-            <a:endParaRPr lang="de-CH" dirty="0"/>
-          </a:p>
-        </p:txBody>
-      </p:sp>
-      <p:pic>
-        <p:nvPicPr>
-          <p:cNvPr id="1026" name="Picture 2" descr="Berner Fachhochschule BFH | Bring Your ...">
-            <a:extLst>
-              <a:ext uri="{FF2B5EF4-FFF2-40B4-BE49-F238E27FC236}">
-                <a16:creationId xmlns:a16="http://schemas.microsoft.com/office/drawing/2014/main" id="{EB382F1C-93FD-77F0-34D7-5B431720FB97}"/>
-              </a:ext>
-            </a:extLst>
-          </p:cNvPr>
-          <p:cNvPicPr>
-            <a:picLocks noChangeAspect="1" noChangeArrowheads="1"/>
-          </p:cNvPicPr>
-          <p:nvPr/>
-        </p:nvPicPr>
-        <p:blipFill>
-          <a:blip r:embed="rId2">
-            <a:extLst>
-              <a:ext uri="{28A0092B-C50C-407E-A947-70E740481C1C}">
-                <a14:useLocalDpi xmlns:a14="http://schemas.microsoft.com/office/drawing/2010/main" val="0"/>
-              </a:ext>
-            </a:extLst>
-          </a:blip>
-          <a:srcRect/>
-          <a:stretch>
-            <a:fillRect/>
-          </a:stretch>
-        </p:blipFill>
-        <p:spPr bwMode="auto">
-          <a:xfrm>
-            <a:off x="518989" y="6935957"/>
-            <a:ext cx="11000705" cy="3811267"/>
-          </a:xfrm>
-          <a:prstGeom prst="rect">
-            <a:avLst/>
-          </a:prstGeom>
-          <a:noFill/>
-          <a:extLst>
-            <a:ext uri="{909E8E84-426E-40DD-AFC4-6F175D3DCCD1}">
-              <a14:hiddenFill xmlns:a14="http://schemas.microsoft.com/office/drawing/2010/main">
-                <a:solidFill>
-                  <a:srgbClr val="FFFFFF"/>
-                </a:solidFill>
-              </a14:hiddenFill>
-            </a:ext>
-          </a:extLst>
-        </p:spPr>
-      </p:pic>
-      <p:pic>
-        <p:nvPicPr>
-          <p:cNvPr id="4" name="Picture 2" descr="Berner Fachhochschule BFH | Bring Your ...">
-            <a:extLst>
-              <a:ext uri="{FF2B5EF4-FFF2-40B4-BE49-F238E27FC236}">
-                <a16:creationId xmlns:a16="http://schemas.microsoft.com/office/drawing/2014/main" id="{5AAF2711-E400-9E58-C80D-B32CB4EB222A}"/>
-              </a:ext>
-            </a:extLst>
-          </p:cNvPr>
-          <p:cNvPicPr>
-            <a:picLocks noChangeAspect="1" noChangeArrowheads="1"/>
-          </p:cNvPicPr>
-          <p:nvPr/>
-        </p:nvPicPr>
-        <p:blipFill>
-          <a:blip r:embed="rId2">
-            <a:extLst>
-              <a:ext uri="{28A0092B-C50C-407E-A947-70E740481C1C}">
-                <a14:useLocalDpi xmlns:a14="http://schemas.microsoft.com/office/drawing/2010/main" val="0"/>
-              </a:ext>
-            </a:extLst>
-          </a:blip>
-          <a:srcRect/>
-          <a:stretch>
-            <a:fillRect/>
-          </a:stretch>
-        </p:blipFill>
-        <p:spPr bwMode="auto">
-          <a:xfrm>
-            <a:off x="11666840" y="6935957"/>
-            <a:ext cx="11000705" cy="3811267"/>
-          </a:xfrm>
-          <a:prstGeom prst="rect">
-            <a:avLst/>
-          </a:prstGeom>
-          <a:noFill/>
-          <a:extLst>
-            <a:ext uri="{909E8E84-426E-40DD-AFC4-6F175D3DCCD1}">
-              <a14:hiddenFill xmlns:a14="http://schemas.microsoft.com/office/drawing/2010/main">
-                <a:solidFill>
-                  <a:srgbClr val="FFFFFF"/>
-                </a:solidFill>
-              </a14:hiddenFill>
-            </a:ext>
-          </a:extLst>
-        </p:spPr>
-      </p:pic>
-    </p:spTree>
-    <p:extLst>
-      <p:ext uri="{BB962C8B-B14F-4D97-AF65-F5344CB8AC3E}">
-        <p14:creationId xmlns:p14="http://schemas.microsoft.com/office/powerpoint/2010/main" val="1784622486"/>
-      </p:ext>
-    </p:extLst>
-  </p:cSld>
-  <p:clrMapOvr>
-    <a:masterClrMapping/>
-  </p:clrMapOvr>
-</p:sld>
-</file>
-
-<file path=ppt/slides/slide3.xml><?xml version="1.0" encoding="utf-8"?>
 <p:sld xmlns:a="http://schemas.openxmlformats.org/drawingml/2006/main" xmlns:r="http://schemas.openxmlformats.org/officeDocument/2006/relationships" xmlns:p="http://schemas.openxmlformats.org/presentationml/2006/main">
   <p:cSld>
     <p:bg>
@@ -3323,6 +3151,349 @@
     <p:extLst>
       <p:ext uri="{BB962C8B-B14F-4D97-AF65-F5344CB8AC3E}">
         <p14:creationId xmlns:p14="http://schemas.microsoft.com/office/powerpoint/2010/main" val="1343610295"/>
+      </p:ext>
+    </p:extLst>
+  </p:cSld>
+  <p:clrMapOvr>
+    <a:masterClrMapping/>
+  </p:clrMapOvr>
+</p:sld>
+</file>
+
+<file path=ppt/slides/slide3.xml><?xml version="1.0" encoding="utf-8"?>
+<p:sld xmlns:a="http://schemas.openxmlformats.org/drawingml/2006/main" xmlns:r="http://schemas.openxmlformats.org/officeDocument/2006/relationships" xmlns:p="http://schemas.openxmlformats.org/presentationml/2006/main">
+  <p:cSld>
+    <p:spTree>
+      <p:nvGrpSpPr>
+        <p:cNvPr id="1" name="">
+          <a:extLst>
+            <a:ext uri="{FF2B5EF4-FFF2-40B4-BE49-F238E27FC236}">
+              <a16:creationId xmlns:a16="http://schemas.microsoft.com/office/drawing/2014/main" id="{1CC33409-F679-693A-B223-4BD2BB6E8B14}"/>
+            </a:ext>
+          </a:extLst>
+        </p:cNvPr>
+        <p:cNvGrpSpPr/>
+        <p:nvPr/>
+      </p:nvGrpSpPr>
+      <p:grpSpPr>
+        <a:xfrm>
+          <a:off x="0" y="0"/>
+          <a:ext cx="0" cy="0"/>
+          <a:chOff x="0" y="0"/>
+          <a:chExt cx="0" cy="0"/>
+        </a:xfrm>
+      </p:grpSpPr>
+      <p:sp>
+        <p:nvSpPr>
+          <p:cNvPr id="2" name="Titel 1">
+            <a:extLst>
+              <a:ext uri="{FF2B5EF4-FFF2-40B4-BE49-F238E27FC236}">
+                <a16:creationId xmlns:a16="http://schemas.microsoft.com/office/drawing/2014/main" id="{C8DDFFD1-77B5-D83C-F7EC-C5377D0FF024}"/>
+              </a:ext>
+            </a:extLst>
+          </p:cNvPr>
+          <p:cNvSpPr>
+            <a:spLocks noGrp="1"/>
+          </p:cNvSpPr>
+          <p:nvPr>
+            <p:ph type="ctrTitle"/>
+          </p:nvPr>
+        </p:nvSpPr>
+        <p:spPr>
+          <a:xfrm>
+            <a:off x="3086176" y="510638"/>
+            <a:ext cx="17161328" cy="4073893"/>
+          </a:xfrm>
+        </p:spPr>
+        <p:txBody>
+          <a:bodyPr anchor="t">
+            <a:noAutofit/>
+          </a:bodyPr>
+          <a:lstStyle/>
+          <a:p>
+            <a:r>
+              <a:rPr lang="de-CH" sz="13100" dirty="0"/>
+              <a:t>Herzlich Willkommen</a:t>
+            </a:r>
+            <a:endParaRPr lang="de-CH" sz="7200" dirty="0"/>
+          </a:p>
+        </p:txBody>
+      </p:sp>
+      <p:sp>
+        <p:nvSpPr>
+          <p:cNvPr id="3" name="Untertitel 2">
+            <a:extLst>
+              <a:ext uri="{FF2B5EF4-FFF2-40B4-BE49-F238E27FC236}">
+                <a16:creationId xmlns:a16="http://schemas.microsoft.com/office/drawing/2014/main" id="{A68D77BB-1357-59BA-76D6-22551424AF62}"/>
+              </a:ext>
+            </a:extLst>
+          </p:cNvPr>
+          <p:cNvSpPr>
+            <a:spLocks noGrp="1"/>
+          </p:cNvSpPr>
+          <p:nvPr>
+            <p:ph type="subTitle" idx="1"/>
+          </p:nvPr>
+        </p:nvSpPr>
+        <p:spPr>
+          <a:xfrm>
+            <a:off x="6947694" y="4524413"/>
+            <a:ext cx="8193345" cy="1484501"/>
+          </a:xfrm>
+        </p:spPr>
+        <p:txBody>
+          <a:bodyPr/>
+          <a:lstStyle/>
+          <a:p>
+            <a:r>
+              <a:rPr lang="de-CH" sz="4800" dirty="0"/>
+              <a:t>Sponsoren</a:t>
+            </a:r>
+            <a:endParaRPr lang="de-CH" dirty="0"/>
+          </a:p>
+        </p:txBody>
+      </p:sp>
+      <p:pic>
+        <p:nvPicPr>
+          <p:cNvPr id="6" name="Picture 2" descr="Werbung Silhouette">
+            <a:extLst>
+              <a:ext uri="{FF2B5EF4-FFF2-40B4-BE49-F238E27FC236}">
+                <a16:creationId xmlns:a16="http://schemas.microsoft.com/office/drawing/2014/main" id="{34168CD4-E900-0E85-2AAF-FF3F62B9C522}"/>
+              </a:ext>
+            </a:extLst>
+          </p:cNvPr>
+          <p:cNvPicPr>
+            <a:picLocks noChangeAspect="1" noChangeArrowheads="1"/>
+          </p:cNvPicPr>
+          <p:nvPr/>
+        </p:nvPicPr>
+        <p:blipFill>
+          <a:blip>
+            <a:extLst>
+              <a:ext uri="{96DAC541-7B7A-43D3-8B79-37D633B846F1}">
+                <asvg:svgBlip xmlns:asvg="http://schemas.microsoft.com/office/drawing/2016/SVG/main" r:embed="rId2"/>
+              </a:ext>
+            </a:extLst>
+          </a:blip>
+          <a:srcRect/>
+          <a:stretch/>
+        </p:blipFill>
+        <p:spPr bwMode="auto">
+          <a:xfrm>
+            <a:off x="216296" y="4921875"/>
+            <a:ext cx="6815945" cy="6815945"/>
+          </a:xfrm>
+          <a:prstGeom prst="rect">
+            <a:avLst/>
+          </a:prstGeom>
+          <a:noFill/>
+        </p:spPr>
+      </p:pic>
+      <p:sp>
+        <p:nvSpPr>
+          <p:cNvPr id="7" name="Textfeld 6">
+            <a:extLst>
+              <a:ext uri="{FF2B5EF4-FFF2-40B4-BE49-F238E27FC236}">
+                <a16:creationId xmlns:a16="http://schemas.microsoft.com/office/drawing/2014/main" id="{C619B6BA-2E68-ABDC-9BB9-B880F49A14BD}"/>
+              </a:ext>
+            </a:extLst>
+          </p:cNvPr>
+          <p:cNvSpPr txBox="1"/>
+          <p:nvPr/>
+        </p:nvSpPr>
+        <p:spPr>
+          <a:xfrm>
+            <a:off x="1094428" y="6304412"/>
+            <a:ext cx="5059680" cy="2585323"/>
+          </a:xfrm>
+          <a:prstGeom prst="rect">
+            <a:avLst/>
+          </a:prstGeom>
+          <a:noFill/>
+        </p:spPr>
+        <p:txBody>
+          <a:bodyPr wrap="square" rtlCol="0">
+            <a:spAutoFit/>
+          </a:bodyPr>
+          <a:lstStyle/>
+          <a:p>
+            <a:pPr algn="ctr"/>
+            <a:r>
+              <a:rPr lang="de-CH" sz="5400" dirty="0">
+                <a:ln w="0"/>
+                <a:solidFill>
+                  <a:schemeClr val="bg1">
+                    <a:lumMod val="50000"/>
+                  </a:schemeClr>
+                </a:solidFill>
+              </a:rPr>
+              <a:t>HIER KÖNNTE IHRE WERBUNG STEHEN</a:t>
+            </a:r>
+          </a:p>
+        </p:txBody>
+      </p:sp>
+      <p:pic>
+        <p:nvPicPr>
+          <p:cNvPr id="8" name="Picture 2" descr="Werbung Silhouette">
+            <a:extLst>
+              <a:ext uri="{FF2B5EF4-FFF2-40B4-BE49-F238E27FC236}">
+                <a16:creationId xmlns:a16="http://schemas.microsoft.com/office/drawing/2014/main" id="{7217C7DA-8C66-8E17-4704-A06E408AEA47}"/>
+              </a:ext>
+            </a:extLst>
+          </p:cNvPr>
+          <p:cNvPicPr>
+            <a:picLocks noChangeAspect="1" noChangeArrowheads="1"/>
+          </p:cNvPicPr>
+          <p:nvPr/>
+        </p:nvPicPr>
+        <p:blipFill>
+          <a:blip>
+            <a:extLst>
+              <a:ext uri="{96DAC541-7B7A-43D3-8B79-37D633B846F1}">
+                <asvg:svgBlip xmlns:asvg="http://schemas.microsoft.com/office/drawing/2016/SVG/main" r:embed="rId2"/>
+              </a:ext>
+            </a:extLst>
+          </a:blip>
+          <a:srcRect/>
+          <a:stretch/>
+        </p:blipFill>
+        <p:spPr bwMode="auto">
+          <a:xfrm>
+            <a:off x="7636393" y="4921877"/>
+            <a:ext cx="6815945" cy="6815945"/>
+          </a:xfrm>
+          <a:prstGeom prst="rect">
+            <a:avLst/>
+          </a:prstGeom>
+          <a:noFill/>
+        </p:spPr>
+      </p:pic>
+      <p:pic>
+        <p:nvPicPr>
+          <p:cNvPr id="9" name="Picture 2" descr="Werbung Silhouette">
+            <a:extLst>
+              <a:ext uri="{FF2B5EF4-FFF2-40B4-BE49-F238E27FC236}">
+                <a16:creationId xmlns:a16="http://schemas.microsoft.com/office/drawing/2014/main" id="{77BEECFB-F06A-297E-2109-2A99C7C680E1}"/>
+              </a:ext>
+            </a:extLst>
+          </p:cNvPr>
+          <p:cNvPicPr>
+            <a:picLocks noChangeAspect="1" noChangeArrowheads="1"/>
+          </p:cNvPicPr>
+          <p:nvPr/>
+        </p:nvPicPr>
+        <p:blipFill>
+          <a:blip>
+            <a:extLst>
+              <a:ext uri="{96DAC541-7B7A-43D3-8B79-37D633B846F1}">
+                <asvg:svgBlip xmlns:asvg="http://schemas.microsoft.com/office/drawing/2016/SVG/main" r:embed="rId2"/>
+              </a:ext>
+            </a:extLst>
+          </a:blip>
+          <a:srcRect/>
+          <a:stretch/>
+        </p:blipFill>
+        <p:spPr bwMode="auto">
+          <a:xfrm>
+            <a:off x="15056492" y="4921876"/>
+            <a:ext cx="6815945" cy="6815945"/>
+          </a:xfrm>
+          <a:prstGeom prst="rect">
+            <a:avLst/>
+          </a:prstGeom>
+          <a:noFill/>
+        </p:spPr>
+      </p:pic>
+      <p:sp>
+        <p:nvSpPr>
+          <p:cNvPr id="10" name="Textfeld 9">
+            <a:extLst>
+              <a:ext uri="{FF2B5EF4-FFF2-40B4-BE49-F238E27FC236}">
+                <a16:creationId xmlns:a16="http://schemas.microsoft.com/office/drawing/2014/main" id="{CD587692-7647-93F7-CAA3-C5D0F1BB219A}"/>
+              </a:ext>
+            </a:extLst>
+          </p:cNvPr>
+          <p:cNvSpPr txBox="1"/>
+          <p:nvPr/>
+        </p:nvSpPr>
+        <p:spPr>
+          <a:xfrm>
+            <a:off x="8514525" y="6346259"/>
+            <a:ext cx="5059680" cy="2585323"/>
+          </a:xfrm>
+          <a:prstGeom prst="rect">
+            <a:avLst/>
+          </a:prstGeom>
+          <a:noFill/>
+        </p:spPr>
+        <p:txBody>
+          <a:bodyPr wrap="square" rtlCol="0">
+            <a:spAutoFit/>
+          </a:bodyPr>
+          <a:lstStyle/>
+          <a:p>
+            <a:pPr algn="ctr"/>
+            <a:r>
+              <a:rPr lang="de-CH" sz="5400" dirty="0">
+                <a:ln w="0"/>
+                <a:solidFill>
+                  <a:schemeClr val="bg1">
+                    <a:lumMod val="50000"/>
+                  </a:schemeClr>
+                </a:solidFill>
+              </a:rPr>
+              <a:t>HIER KÖNNTE IHRE WERBUNG STEHEN</a:t>
+            </a:r>
+          </a:p>
+        </p:txBody>
+      </p:sp>
+      <p:sp>
+        <p:nvSpPr>
+          <p:cNvPr id="11" name="Textfeld 10">
+            <a:extLst>
+              <a:ext uri="{FF2B5EF4-FFF2-40B4-BE49-F238E27FC236}">
+                <a16:creationId xmlns:a16="http://schemas.microsoft.com/office/drawing/2014/main" id="{9757C0D6-8880-BC87-6871-9FB2310D7269}"/>
+              </a:ext>
+            </a:extLst>
+          </p:cNvPr>
+          <p:cNvSpPr txBox="1"/>
+          <p:nvPr/>
+        </p:nvSpPr>
+        <p:spPr>
+          <a:xfrm>
+            <a:off x="15934624" y="6304412"/>
+            <a:ext cx="5059680" cy="2585323"/>
+          </a:xfrm>
+          <a:prstGeom prst="rect">
+            <a:avLst/>
+          </a:prstGeom>
+          <a:noFill/>
+        </p:spPr>
+        <p:txBody>
+          <a:bodyPr wrap="square" rtlCol="0">
+            <a:spAutoFit/>
+          </a:bodyPr>
+          <a:lstStyle/>
+          <a:p>
+            <a:pPr algn="ctr"/>
+            <a:r>
+              <a:rPr lang="de-CH" sz="5400" dirty="0">
+                <a:ln w="0"/>
+                <a:solidFill>
+                  <a:schemeClr val="bg1">
+                    <a:lumMod val="50000"/>
+                  </a:schemeClr>
+                </a:solidFill>
+              </a:rPr>
+              <a:t>HIER KÖNNTE IHRE WERBUNG STEHEN</a:t>
+            </a:r>
+          </a:p>
+        </p:txBody>
+      </p:sp>
+    </p:spTree>
+    <p:extLst>
+      <p:ext uri="{BB962C8B-B14F-4D97-AF65-F5344CB8AC3E}">
+        <p14:creationId xmlns:p14="http://schemas.microsoft.com/office/powerpoint/2010/main" val="1784622486"/>
       </p:ext>
     </p:extLst>
   </p:cSld>
@@ -3403,6 +3574,98 @@
     <p:extLst>
       <p:ext uri="{BB962C8B-B14F-4D97-AF65-F5344CB8AC3E}">
         <p14:creationId xmlns:p14="http://schemas.microsoft.com/office/powerpoint/2010/main" val="2596078582"/>
+      </p:ext>
+    </p:extLst>
+  </p:cSld>
+  <p:clrMapOvr>
+    <a:masterClrMapping/>
+  </p:clrMapOvr>
+</p:sld>
+</file>
+
+<file path=ppt/slides/slide5.xml><?xml version="1.0" encoding="utf-8"?>
+<p:sld xmlns:a="http://schemas.openxmlformats.org/drawingml/2006/main" xmlns:r="http://schemas.openxmlformats.org/officeDocument/2006/relationships" xmlns:p="http://schemas.openxmlformats.org/presentationml/2006/main">
+  <p:cSld>
+    <p:bg>
+      <p:bgPr>
+        <a:blipFill dpi="0" rotWithShape="1">
+          <a:blip>
+            <a:lum/>
+            <a:extLst>
+              <a:ext uri="{96DAC541-7B7A-43D3-8B79-37D633B846F1}">
+                <asvg:svgBlip xmlns:asvg="http://schemas.microsoft.com/office/drawing/2016/SVG/main" r:embed="rId2"/>
+              </a:ext>
+            </a:extLst>
+          </a:blip>
+          <a:srcRect/>
+          <a:stretch>
+            <a:fillRect/>
+          </a:stretch>
+        </a:blipFill>
+        <a:effectLst/>
+      </p:bgPr>
+    </p:bg>
+    <p:spTree>
+      <p:nvGrpSpPr>
+        <p:cNvPr id="1" name=""/>
+        <p:cNvGrpSpPr/>
+        <p:nvPr/>
+      </p:nvGrpSpPr>
+      <p:grpSpPr>
+        <a:xfrm>
+          <a:off x="0" y="0"/>
+          <a:ext cx="0" cy="0"/>
+          <a:chOff x="0" y="0"/>
+          <a:chExt cx="0" cy="0"/>
+        </a:xfrm>
+      </p:grpSpPr>
+      <p:sp>
+        <p:nvSpPr>
+          <p:cNvPr id="3" name="Textfeld 2">
+            <a:extLst>
+              <a:ext uri="{FF2B5EF4-FFF2-40B4-BE49-F238E27FC236}">
+                <a16:creationId xmlns:a16="http://schemas.microsoft.com/office/drawing/2014/main" id="{A5A2B25F-6A9F-EBA6-1DEB-56A6F4856C35}"/>
+              </a:ext>
+            </a:extLst>
+          </p:cNvPr>
+          <p:cNvSpPr txBox="1"/>
+          <p:nvPr/>
+        </p:nvSpPr>
+        <p:spPr>
+          <a:xfrm>
+            <a:off x="3111594" y="2646812"/>
+            <a:ext cx="16816200" cy="3631763"/>
+          </a:xfrm>
+          <a:prstGeom prst="rect">
+            <a:avLst/>
+          </a:prstGeom>
+          <a:noFill/>
+        </p:spPr>
+        <p:txBody>
+          <a:bodyPr wrap="square" rtlCol="0">
+            <a:spAutoFit/>
+          </a:bodyPr>
+          <a:lstStyle/>
+          <a:p>
+            <a:pPr algn="ctr"/>
+            <a:r>
+              <a:rPr lang="de-CH" sz="11500" dirty="0">
+                <a:ln w="0"/>
+                <a:solidFill>
+                  <a:schemeClr val="bg1">
+                    <a:lumMod val="50000"/>
+                  </a:schemeClr>
+                </a:solidFill>
+              </a:rPr>
+              <a:t>HIER KÖNNTE IHRE WERBUNG STEHEN</a:t>
+            </a:r>
+          </a:p>
+        </p:txBody>
+      </p:sp>
+    </p:spTree>
+    <p:extLst>
+      <p:ext uri="{BB962C8B-B14F-4D97-AF65-F5344CB8AC3E}">
+        <p14:creationId xmlns:p14="http://schemas.microsoft.com/office/powerpoint/2010/main" val="3054940411"/>
       </p:ext>
     </p:extLst>
   </p:cSld>

</xml_diff>